<commit_message>
feat: ajout filtrage temporel RAG + date dans prompt + fix Ollama->Mistral evaluate_rag
</commit_message>
<xml_diff>
--- a/P11_Categorisez_automatiquement_des_questions_aymeric_bailleul/_projet/_docs/ABAI_P11_02_presentation_20260216.pptx
+++ b/P11_Categorisez_automatiquement_des_questions_aymeric_bailleul/_projet/_docs/ABAI_P11_02_presentation_20260216.pptx
@@ -211,7 +211,7 @@
           <a:p>
             <a:fld id="{FC1C4A0D-7723-4A92-ABBB-96643D195969}" type="datetimeFigureOut">
               <a:rPr lang="fr-FR" smtClean="0"/>
-              <a:t>25/02/2026</a:t>
+              <a:t>26/02/2026</a:t>
             </a:fld>
             <a:endParaRPr lang="fr-FR"/>
           </a:p>
@@ -950,6 +950,295 @@
           <a:bodyPr/>
           <a:lstStyle/>
           <a:p>
+            <a:pPr marL="0" marR="0" lvl="0" indent="0" algn="l" defTabSz="914400" rtl="0" eaLnBrk="1" fontAlgn="auto" latinLnBrk="0" hangingPunct="1">
+              <a:lnSpc>
+                <a:spcPct val="100000"/>
+              </a:lnSpc>
+              <a:spcBef>
+                <a:spcPts val="0"/>
+              </a:spcBef>
+              <a:spcAft>
+                <a:spcPts val="0"/>
+              </a:spcAft>
+              <a:buClrTx/>
+              <a:buSzTx/>
+              <a:buFontTx/>
+              <a:buNone/>
+              <a:tabLst/>
+              <a:defRPr/>
+            </a:pPr>
+            <a:r>
+              <a:rPr lang="fr-FR" sz="1200" b="0" kern="1200" dirty="0" err="1">
+                <a:solidFill>
+                  <a:schemeClr val="tx1"/>
+                </a:solidFill>
+                <a:effectLst/>
+                <a:latin typeface="+mn-lt"/>
+                <a:ea typeface="+mn-ea"/>
+                <a:cs typeface="+mn-cs"/>
+              </a:rPr>
+              <a:t>Faithfulness</a:t>
+            </a:r>
+            <a:r>
+              <a:rPr lang="fr-FR" sz="1200" b="0" kern="1200" dirty="0">
+                <a:solidFill>
+                  <a:schemeClr val="tx1"/>
+                </a:solidFill>
+                <a:effectLst/>
+                <a:latin typeface="+mn-lt"/>
+                <a:ea typeface="+mn-ea"/>
+                <a:cs typeface="+mn-cs"/>
+              </a:rPr>
+              <a:t> = Génération : fidèle au contexte ?</a:t>
+            </a:r>
+          </a:p>
+          <a:p>
+            <a:r>
+              <a:rPr lang="fr-FR" sz="1200" b="0" kern="1200" dirty="0" err="1">
+                <a:solidFill>
+                  <a:schemeClr val="tx1"/>
+                </a:solidFill>
+                <a:effectLst/>
+                <a:latin typeface="+mn-lt"/>
+                <a:ea typeface="+mn-ea"/>
+                <a:cs typeface="+mn-cs"/>
+              </a:rPr>
+              <a:t>answer_relevancy</a:t>
+            </a:r>
+            <a:r>
+              <a:rPr lang="fr-FR" sz="1200" b="0" kern="1200" dirty="0">
+                <a:solidFill>
+                  <a:schemeClr val="tx1"/>
+                </a:solidFill>
+                <a:effectLst/>
+                <a:latin typeface="+mn-lt"/>
+                <a:ea typeface="+mn-ea"/>
+                <a:cs typeface="+mn-cs"/>
+              </a:rPr>
+              <a:t> = Génération : réponse pertinente à la question ?</a:t>
+            </a:r>
+          </a:p>
+          <a:p>
+            <a:r>
+              <a:rPr lang="fr-FR" sz="1200" b="0" kern="1200" dirty="0" err="1">
+                <a:solidFill>
+                  <a:schemeClr val="tx1"/>
+                </a:solidFill>
+                <a:effectLst/>
+                <a:latin typeface="+mn-lt"/>
+                <a:ea typeface="+mn-ea"/>
+                <a:cs typeface="+mn-cs"/>
+              </a:rPr>
+              <a:t>context_precision</a:t>
+            </a:r>
+            <a:r>
+              <a:rPr lang="fr-FR" sz="1200" b="0" kern="1200" dirty="0">
+                <a:solidFill>
+                  <a:schemeClr val="tx1"/>
+                </a:solidFill>
+                <a:effectLst/>
+                <a:latin typeface="+mn-lt"/>
+                <a:ea typeface="+mn-ea"/>
+                <a:cs typeface="+mn-cs"/>
+              </a:rPr>
+              <a:t> = Récupération : contexte précis (peu de bruit) ?</a:t>
+            </a:r>
+          </a:p>
+          <a:p>
+            <a:r>
+              <a:rPr lang="fr-FR" sz="1200" b="0" kern="1200" dirty="0" err="1">
+                <a:solidFill>
+                  <a:schemeClr val="tx1"/>
+                </a:solidFill>
+                <a:effectLst/>
+                <a:latin typeface="+mn-lt"/>
+                <a:ea typeface="+mn-ea"/>
+                <a:cs typeface="+mn-cs"/>
+              </a:rPr>
+              <a:t>context_recall</a:t>
+            </a:r>
+            <a:r>
+              <a:rPr lang="fr-FR" sz="1200" b="0" kern="1200" dirty="0">
+                <a:solidFill>
+                  <a:schemeClr val="tx1"/>
+                </a:solidFill>
+                <a:effectLst/>
+                <a:latin typeface="+mn-lt"/>
+                <a:ea typeface="+mn-ea"/>
+                <a:cs typeface="+mn-cs"/>
+              </a:rPr>
+              <a:t> = Récupération : infos clés récupérées (nécessite </a:t>
+            </a:r>
+            <a:r>
+              <a:rPr lang="fr-FR" sz="1200" b="0" kern="1200" dirty="0" err="1">
+                <a:solidFill>
+                  <a:schemeClr val="tx1"/>
+                </a:solidFill>
+                <a:effectLst/>
+                <a:latin typeface="+mn-lt"/>
+                <a:ea typeface="+mn-ea"/>
+                <a:cs typeface="+mn-cs"/>
+              </a:rPr>
+              <a:t>ground_truth</a:t>
+            </a:r>
+            <a:r>
+              <a:rPr lang="fr-FR" sz="1200" b="0" kern="1200" dirty="0">
+                <a:solidFill>
+                  <a:schemeClr val="tx1"/>
+                </a:solidFill>
+                <a:effectLst/>
+                <a:latin typeface="+mn-lt"/>
+                <a:ea typeface="+mn-ea"/>
+                <a:cs typeface="+mn-cs"/>
+              </a:rPr>
+              <a:t>) ?</a:t>
+            </a:r>
+          </a:p>
+          <a:p>
+            <a:pPr algn="l"/>
+            <a:endParaRPr lang="fr-FR" sz="1200" b="0" dirty="0">
+              <a:solidFill>
+                <a:schemeClr val="bg1"/>
+              </a:solidFill>
+            </a:endParaRPr>
+          </a:p>
+          <a:p>
+            <a:pPr algn="l"/>
+            <a:r>
+              <a:rPr lang="fr-FR" sz="1200" b="0" dirty="0">
+                <a:solidFill>
+                  <a:schemeClr val="bg1"/>
+                </a:solidFill>
+              </a:rPr>
+              <a:t>Point fort : </a:t>
+            </a:r>
+            <a:r>
+              <a:rPr lang="fr-FR" sz="1200" b="0" dirty="0" err="1">
+                <a:solidFill>
+                  <a:schemeClr val="bg1"/>
+                </a:solidFill>
+              </a:rPr>
+              <a:t>answer_relevancy</a:t>
+            </a:r>
+            <a:r>
+              <a:rPr lang="fr-FR" sz="1200" b="0" dirty="0">
+                <a:solidFill>
+                  <a:schemeClr val="bg1"/>
+                </a:solidFill>
+              </a:rPr>
+              <a:t> = 0.910 — le LLM formule des réponses de qualité</a:t>
+            </a:r>
+          </a:p>
+          <a:p>
+            <a:pPr algn="l"/>
+            <a:r>
+              <a:rPr lang="fr-FR" sz="1200" b="0" dirty="0">
+                <a:solidFill>
+                  <a:schemeClr val="bg1"/>
+                </a:solidFill>
+              </a:rPr>
+              <a:t>Point faible : </a:t>
+            </a:r>
+            <a:r>
+              <a:rPr lang="fr-FR" sz="1200" b="0" dirty="0" err="1">
+                <a:solidFill>
+                  <a:schemeClr val="bg1"/>
+                </a:solidFill>
+              </a:rPr>
+              <a:t>context_recall</a:t>
+            </a:r>
+            <a:r>
+              <a:rPr lang="fr-FR" sz="1200" b="0" dirty="0">
+                <a:solidFill>
+                  <a:schemeClr val="bg1"/>
+                </a:solidFill>
+              </a:rPr>
+              <a:t> = 0.583 — on ne récupère pas toujours tous les passages utiles avec 10 blocs</a:t>
+            </a:r>
+          </a:p>
+          <a:p>
+            <a:pPr algn="l"/>
+            <a:endParaRPr lang="fr-FR" sz="1200" b="0" dirty="0">
+              <a:solidFill>
+                <a:schemeClr val="bg1"/>
+              </a:solidFill>
+            </a:endParaRPr>
+          </a:p>
+          <a:p>
+            <a:r>
+              <a:rPr lang="fr-FR" sz="1200" b="1" kern="1200" dirty="0">
+                <a:solidFill>
+                  <a:schemeClr val="tx1"/>
+                </a:solidFill>
+                <a:effectLst/>
+                <a:latin typeface="+mn-lt"/>
+                <a:ea typeface="+mn-ea"/>
+                <a:cs typeface="+mn-cs"/>
+              </a:rPr>
+              <a:t>Le problème de l'évaluation subjective : </a:t>
+            </a:r>
+            <a:r>
+              <a:rPr lang="fr-FR" sz="1200" b="0" kern="1200" dirty="0">
+                <a:solidFill>
+                  <a:schemeClr val="tx1"/>
+                </a:solidFill>
+                <a:effectLst/>
+                <a:latin typeface="+mn-lt"/>
+                <a:ea typeface="+mn-ea"/>
+                <a:cs typeface="+mn-cs"/>
+              </a:rPr>
+              <a:t>Dire "les réponses ont l'air bonnes" ne suffit pas. Il faut des indicateurs objectifs, reproductibles, qui séparent les deux composantes du système : le </a:t>
+            </a:r>
+            <a:r>
+              <a:rPr lang="fr-FR" sz="1200" b="1" kern="1200" dirty="0">
+                <a:solidFill>
+                  <a:schemeClr val="tx1"/>
+                </a:solidFill>
+                <a:effectLst/>
+                <a:latin typeface="+mn-lt"/>
+                <a:ea typeface="+mn-ea"/>
+                <a:cs typeface="+mn-cs"/>
+              </a:rPr>
+              <a:t>**retriever**</a:t>
+            </a:r>
+            <a:r>
+              <a:rPr lang="fr-FR" sz="1200" b="0" kern="1200" dirty="0">
+                <a:solidFill>
+                  <a:schemeClr val="tx1"/>
+                </a:solidFill>
+                <a:effectLst/>
+                <a:latin typeface="+mn-lt"/>
+                <a:ea typeface="+mn-ea"/>
+                <a:cs typeface="+mn-cs"/>
+              </a:rPr>
+              <a:t> (a-t-il trouvé les bons passages ?) et le </a:t>
+            </a:r>
+            <a:r>
+              <a:rPr lang="fr-FR" sz="1200" b="1" kern="1200" dirty="0">
+                <a:solidFill>
+                  <a:schemeClr val="tx1"/>
+                </a:solidFill>
+                <a:effectLst/>
+                <a:latin typeface="+mn-lt"/>
+                <a:ea typeface="+mn-ea"/>
+                <a:cs typeface="+mn-cs"/>
+              </a:rPr>
+              <a:t>**LLM**</a:t>
+            </a:r>
+            <a:r>
+              <a:rPr lang="fr-FR" sz="1200" b="0" kern="1200" dirty="0">
+                <a:solidFill>
+                  <a:schemeClr val="tx1"/>
+                </a:solidFill>
+                <a:effectLst/>
+                <a:latin typeface="+mn-lt"/>
+                <a:ea typeface="+mn-ea"/>
+                <a:cs typeface="+mn-cs"/>
+              </a:rPr>
+              <a:t> (a-t-il bien répondu avec ces passages ?).</a:t>
+            </a:r>
+          </a:p>
+          <a:p>
             <a:pPr algn="l"/>
             <a:endParaRPr lang="fr-FR" sz="1200" b="0" kern="1200" dirty="0">
               <a:solidFill>
@@ -1180,139 +1469,15 @@
           <a:lstStyle/>
           <a:p>
             <a:pPr algn="l"/>
-            <a:r>
-              <a:rPr lang="fr-FR" sz="1200" b="0" dirty="0">
-                <a:solidFill>
-                  <a:schemeClr val="bg1"/>
-                </a:solidFill>
-              </a:rPr>
-              <a:t>Point fort : </a:t>
-            </a:r>
-            <a:r>
-              <a:rPr lang="fr-FR" sz="1200" b="0" dirty="0" err="1">
-                <a:solidFill>
-                  <a:schemeClr val="bg1"/>
-                </a:solidFill>
-              </a:rPr>
-              <a:t>answer_relevancy</a:t>
-            </a:r>
-            <a:r>
-              <a:rPr lang="fr-FR" sz="1200" b="0" dirty="0">
-                <a:solidFill>
-                  <a:schemeClr val="bg1"/>
-                </a:solidFill>
-              </a:rPr>
-              <a:t> = 0.910 — le LLM formule des réponses de qualité</a:t>
-            </a:r>
-          </a:p>
-          <a:p>
-            <a:pPr algn="l"/>
-            <a:r>
-              <a:rPr lang="fr-FR" sz="1200" b="0" dirty="0">
-                <a:solidFill>
-                  <a:schemeClr val="bg1"/>
-                </a:solidFill>
-              </a:rPr>
-              <a:t>Point faible : </a:t>
-            </a:r>
-            <a:r>
-              <a:rPr lang="fr-FR" sz="1200" b="0" dirty="0" err="1">
-                <a:solidFill>
-                  <a:schemeClr val="bg1"/>
-                </a:solidFill>
-              </a:rPr>
-              <a:t>context_recall</a:t>
-            </a:r>
-            <a:r>
-              <a:rPr lang="fr-FR" sz="1200" b="0" dirty="0">
-                <a:solidFill>
-                  <a:schemeClr val="bg1"/>
-                </a:solidFill>
-              </a:rPr>
-              <a:t> = 0.583 — on ne récupère pas toujours tous les passages utiles avec 10 blocs</a:t>
-            </a:r>
-          </a:p>
-          <a:p>
-            <a:pPr algn="l"/>
-            <a:endParaRPr lang="fr-FR" sz="1200" b="0" dirty="0">
+            <a:endParaRPr lang="fr-FR" sz="1200" b="0" kern="1200" dirty="0">
               <a:solidFill>
-                <a:schemeClr val="bg1"/>
+                <a:schemeClr val="tx1"/>
               </a:solidFill>
+              <a:effectLst/>
+              <a:latin typeface="+mn-lt"/>
+              <a:ea typeface="+mn-ea"/>
+              <a:cs typeface="+mn-cs"/>
             </a:endParaRPr>
-          </a:p>
-          <a:p>
-            <a:r>
-              <a:rPr lang="fr-FR" sz="1200" b="1" kern="1200" dirty="0">
-                <a:solidFill>
-                  <a:schemeClr val="tx1"/>
-                </a:solidFill>
-                <a:effectLst/>
-                <a:latin typeface="+mn-lt"/>
-                <a:ea typeface="+mn-ea"/>
-                <a:cs typeface="+mn-cs"/>
-              </a:rPr>
-              <a:t>Le problème de l'évaluation subjective : </a:t>
-            </a:r>
-            <a:r>
-              <a:rPr lang="fr-FR" sz="1200" b="0" kern="1200" dirty="0">
-                <a:solidFill>
-                  <a:schemeClr val="tx1"/>
-                </a:solidFill>
-                <a:effectLst/>
-                <a:latin typeface="+mn-lt"/>
-                <a:ea typeface="+mn-ea"/>
-                <a:cs typeface="+mn-cs"/>
-              </a:rPr>
-              <a:t>Dire "les réponses ont l'air bonnes" ne suffit pas. Il faut des indicateurs objectifs, reproductibles, qui séparent les deux composantes du système : le </a:t>
-            </a:r>
-            <a:r>
-              <a:rPr lang="fr-FR" sz="1200" b="1" kern="1200" dirty="0">
-                <a:solidFill>
-                  <a:schemeClr val="tx1"/>
-                </a:solidFill>
-                <a:effectLst/>
-                <a:latin typeface="+mn-lt"/>
-                <a:ea typeface="+mn-ea"/>
-                <a:cs typeface="+mn-cs"/>
-              </a:rPr>
-              <a:t>**retriever**</a:t>
-            </a:r>
-            <a:r>
-              <a:rPr lang="fr-FR" sz="1200" b="0" kern="1200" dirty="0">
-                <a:solidFill>
-                  <a:schemeClr val="tx1"/>
-                </a:solidFill>
-                <a:effectLst/>
-                <a:latin typeface="+mn-lt"/>
-                <a:ea typeface="+mn-ea"/>
-                <a:cs typeface="+mn-cs"/>
-              </a:rPr>
-              <a:t> (a-t-il trouvé les bons passages ?) et le </a:t>
-            </a:r>
-            <a:r>
-              <a:rPr lang="fr-FR" sz="1200" b="1" kern="1200" dirty="0">
-                <a:solidFill>
-                  <a:schemeClr val="tx1"/>
-                </a:solidFill>
-                <a:effectLst/>
-                <a:latin typeface="+mn-lt"/>
-                <a:ea typeface="+mn-ea"/>
-                <a:cs typeface="+mn-cs"/>
-              </a:rPr>
-              <a:t>**LLM**</a:t>
-            </a:r>
-            <a:r>
-              <a:rPr lang="fr-FR" sz="1200" b="0" kern="1200" dirty="0">
-                <a:solidFill>
-                  <a:schemeClr val="tx1"/>
-                </a:solidFill>
-                <a:effectLst/>
-                <a:latin typeface="+mn-lt"/>
-                <a:ea typeface="+mn-ea"/>
-                <a:cs typeface="+mn-cs"/>
-              </a:rPr>
-              <a:t> (a-t-il bien répondu avec ces passages ?).</a:t>
-            </a:r>
           </a:p>
         </p:txBody>
       </p:sp>
@@ -2750,30 +2915,6 @@
               <a:tabLst/>
               <a:defRPr/>
             </a:pPr>
-            <a:endParaRPr lang="fr-FR" sz="1700" b="0" dirty="0">
-              <a:solidFill>
-                <a:srgbClr val="4CAF50"/>
-              </a:solidFill>
-            </a:endParaRPr>
-          </a:p>
-          <a:p>
-            <a:pPr marL="0" marR="0" lvl="0" indent="0" algn="l" defTabSz="914400" rtl="0" eaLnBrk="1" fontAlgn="auto" latinLnBrk="0" hangingPunct="1">
-              <a:lnSpc>
-                <a:spcPct val="100000"/>
-              </a:lnSpc>
-              <a:spcBef>
-                <a:spcPts val="0"/>
-              </a:spcBef>
-              <a:spcAft>
-                <a:spcPts val="0"/>
-              </a:spcAft>
-              <a:buClrTx/>
-              <a:buSzTx/>
-              <a:buFontTx/>
-              <a:buNone/>
-              <a:tabLst/>
-              <a:defRPr/>
-            </a:pPr>
             <a:r>
               <a:rPr lang="fr-FR" sz="1200" b="1" kern="1200" dirty="0">
                 <a:solidFill>
@@ -3686,7 +3827,7 @@
           <a:p>
             <a:fld id="{F60878AB-3368-4025-A10C-3112E0B9CFA3}" type="datetimeFigureOut">
               <a:rPr lang="fr-FR" smtClean="0"/>
-              <a:t>25/02/2026</a:t>
+              <a:t>26/02/2026</a:t>
             </a:fld>
             <a:endParaRPr lang="fr-FR"/>
           </a:p>
@@ -3884,7 +4025,7 @@
           <a:p>
             <a:fld id="{F60878AB-3368-4025-A10C-3112E0B9CFA3}" type="datetimeFigureOut">
               <a:rPr lang="fr-FR" smtClean="0"/>
-              <a:t>25/02/2026</a:t>
+              <a:t>26/02/2026</a:t>
             </a:fld>
             <a:endParaRPr lang="fr-FR"/>
           </a:p>
@@ -4092,7 +4233,7 @@
           <a:p>
             <a:fld id="{F60878AB-3368-4025-A10C-3112E0B9CFA3}" type="datetimeFigureOut">
               <a:rPr lang="fr-FR" smtClean="0"/>
-              <a:t>25/02/2026</a:t>
+              <a:t>26/02/2026</a:t>
             </a:fld>
             <a:endParaRPr lang="fr-FR"/>
           </a:p>
@@ -4290,7 +4431,7 @@
           <a:p>
             <a:fld id="{F60878AB-3368-4025-A10C-3112E0B9CFA3}" type="datetimeFigureOut">
               <a:rPr lang="fr-FR" smtClean="0"/>
-              <a:t>25/02/2026</a:t>
+              <a:t>26/02/2026</a:t>
             </a:fld>
             <a:endParaRPr lang="fr-FR"/>
           </a:p>
@@ -4565,7 +4706,7 @@
           <a:p>
             <a:fld id="{F60878AB-3368-4025-A10C-3112E0B9CFA3}" type="datetimeFigureOut">
               <a:rPr lang="fr-FR" smtClean="0"/>
-              <a:t>25/02/2026</a:t>
+              <a:t>26/02/2026</a:t>
             </a:fld>
             <a:endParaRPr lang="fr-FR"/>
           </a:p>
@@ -4830,7 +4971,7 @@
           <a:p>
             <a:fld id="{F60878AB-3368-4025-A10C-3112E0B9CFA3}" type="datetimeFigureOut">
               <a:rPr lang="fr-FR" smtClean="0"/>
-              <a:t>25/02/2026</a:t>
+              <a:t>26/02/2026</a:t>
             </a:fld>
             <a:endParaRPr lang="fr-FR"/>
           </a:p>
@@ -5242,7 +5383,7 @@
           <a:p>
             <a:fld id="{F60878AB-3368-4025-A10C-3112E0B9CFA3}" type="datetimeFigureOut">
               <a:rPr lang="fr-FR" smtClean="0"/>
-              <a:t>25/02/2026</a:t>
+              <a:t>26/02/2026</a:t>
             </a:fld>
             <a:endParaRPr lang="fr-FR"/>
           </a:p>
@@ -5383,7 +5524,7 @@
           <a:p>
             <a:fld id="{F60878AB-3368-4025-A10C-3112E0B9CFA3}" type="datetimeFigureOut">
               <a:rPr lang="fr-FR" smtClean="0"/>
-              <a:t>25/02/2026</a:t>
+              <a:t>26/02/2026</a:t>
             </a:fld>
             <a:endParaRPr lang="fr-FR"/>
           </a:p>
@@ -5496,7 +5637,7 @@
           <a:p>
             <a:fld id="{F60878AB-3368-4025-A10C-3112E0B9CFA3}" type="datetimeFigureOut">
               <a:rPr lang="fr-FR" smtClean="0"/>
-              <a:t>25/02/2026</a:t>
+              <a:t>26/02/2026</a:t>
             </a:fld>
             <a:endParaRPr lang="fr-FR"/>
           </a:p>
@@ -5807,7 +5948,7 @@
           <a:p>
             <a:fld id="{F60878AB-3368-4025-A10C-3112E0B9CFA3}" type="datetimeFigureOut">
               <a:rPr lang="fr-FR" smtClean="0"/>
-              <a:t>25/02/2026</a:t>
+              <a:t>26/02/2026</a:t>
             </a:fld>
             <a:endParaRPr lang="fr-FR"/>
           </a:p>
@@ -6095,7 +6236,7 @@
           <a:p>
             <a:fld id="{F60878AB-3368-4025-A10C-3112E0B9CFA3}" type="datetimeFigureOut">
               <a:rPr lang="fr-FR" smtClean="0"/>
-              <a:t>25/02/2026</a:t>
+              <a:t>26/02/2026</a:t>
             </a:fld>
             <a:endParaRPr lang="fr-FR"/>
           </a:p>
@@ -6351,7 +6492,7 @@
           <a:p>
             <a:fld id="{F60878AB-3368-4025-A10C-3112E0B9CFA3}" type="datetimeFigureOut">
               <a:rPr lang="fr-FR" smtClean="0"/>
-              <a:t>25/02/2026</a:t>
+              <a:t>26/02/2026</a:t>
             </a:fld>
             <a:endParaRPr lang="fr-FR"/>
           </a:p>
@@ -8727,6 +8868,42 @@
           <a:chExt cx="0" cy="0"/>
         </a:xfrm>
       </p:grpSpPr>
+      <p:pic>
+        <p:nvPicPr>
+          <p:cNvPr id="10" name="Image 9">
+            <a:extLst>
+              <a:ext uri="{FF2B5EF4-FFF2-40B4-BE49-F238E27FC236}">
+                <a16:creationId xmlns:a16="http://schemas.microsoft.com/office/drawing/2014/main" id="{F6C6E7E0-F549-DD69-C2C0-E5AA99D13159}"/>
+              </a:ext>
+            </a:extLst>
+          </p:cNvPr>
+          <p:cNvPicPr>
+            <a:picLocks noChangeAspect="1"/>
+          </p:cNvPicPr>
+          <p:nvPr/>
+        </p:nvPicPr>
+        <p:blipFill>
+          <a:blip r:embed="rId3">
+            <a:extLst>
+              <a:ext uri="{28A0092B-C50C-407E-A947-70E740481C1C}">
+                <a14:useLocalDpi xmlns:a14="http://schemas.microsoft.com/office/drawing/2010/main" val="0"/>
+              </a:ext>
+            </a:extLst>
+          </a:blip>
+          <a:stretch>
+            <a:fillRect/>
+          </a:stretch>
+        </p:blipFill>
+        <p:spPr>
+          <a:xfrm>
+            <a:off x="3374400" y="850589"/>
+            <a:ext cx="5443200" cy="5590314"/>
+          </a:xfrm>
+          <a:prstGeom prst="rect">
+            <a:avLst/>
+          </a:prstGeom>
+        </p:spPr>
+      </p:pic>
       <p:sp>
         <p:nvSpPr>
           <p:cNvPr id="2" name="ZoneTexte 1">
@@ -10066,6 +10243,42 @@
           </a:graphicData>
         </a:graphic>
       </p:graphicFrame>
+      <p:pic>
+        <p:nvPicPr>
+          <p:cNvPr id="8" name="Image 7">
+            <a:extLst>
+              <a:ext uri="{FF2B5EF4-FFF2-40B4-BE49-F238E27FC236}">
+                <a16:creationId xmlns:a16="http://schemas.microsoft.com/office/drawing/2014/main" id="{70BEF6AB-5435-D791-4C6A-7BDD540DA93A}"/>
+              </a:ext>
+            </a:extLst>
+          </p:cNvPr>
+          <p:cNvPicPr>
+            <a:picLocks noChangeAspect="1"/>
+          </p:cNvPicPr>
+          <p:nvPr/>
+        </p:nvPicPr>
+        <p:blipFill>
+          <a:blip r:embed="rId4">
+            <a:extLst>
+              <a:ext uri="{28A0092B-C50C-407E-A947-70E740481C1C}">
+                <a14:useLocalDpi xmlns:a14="http://schemas.microsoft.com/office/drawing/2010/main" val="0"/>
+              </a:ext>
+            </a:extLst>
+          </a:blip>
+          <a:stretch>
+            <a:fillRect/>
+          </a:stretch>
+        </p:blipFill>
+        <p:spPr>
+          <a:xfrm>
+            <a:off x="9784660" y="1"/>
+            <a:ext cx="2407339" cy="800100"/>
+          </a:xfrm>
+          <a:prstGeom prst="rect">
+            <a:avLst/>
+          </a:prstGeom>
+        </p:spPr>
+      </p:pic>
     </p:spTree>
     <p:extLst>
       <p:ext uri="{BB962C8B-B14F-4D97-AF65-F5344CB8AC3E}">
@@ -11229,7 +11442,7 @@
         <p:spPr>
           <a:xfrm>
             <a:off x="142875" y="950595"/>
-            <a:ext cx="11906250" cy="5478423"/>
+            <a:ext cx="11906250" cy="4893647"/>
           </a:xfrm>
           <a:prstGeom prst="rect">
             <a:avLst/>
@@ -11277,7 +11490,7 @@
                   <a:schemeClr val="bg1"/>
                 </a:solidFill>
               </a:rPr>
-              <a:t>Quels concerts ont lieu à Toulouse en ce moment ?</a:t>
+              <a:t>Quels concerts ont lieu à Toulouse en Mars 2026?</a:t>
             </a:r>
           </a:p>
           <a:p>
@@ -11315,7 +11528,7 @@
                   <a:schemeClr val="bg1"/>
                 </a:solidFill>
               </a:rPr>
-              <a:t>. Il indique s'ils sont passés ou à venir.</a:t>
+              <a:t>. </a:t>
             </a:r>
           </a:p>
           <a:p>
@@ -11382,7 +11595,15 @@
                   <a:schemeClr val="bg1"/>
                 </a:solidFill>
               </a:rPr>
-              <a:t>avec noms de salles et dates. Le LLM précise "adapté aux enfants" ou "tout public".</a:t>
+              <a:t>avec noms de salles et dates</a:t>
+            </a:r>
+            <a:r>
+              <a:rPr lang="fr-FR">
+                <a:solidFill>
+                  <a:schemeClr val="bg1"/>
+                </a:solidFill>
+              </a:rPr>
+              <a:t>. </a:t>
             </a:r>
           </a:p>
           <a:p>
@@ -11500,7 +11721,7 @@
                   <a:schemeClr val="bg1"/>
                 </a:solidFill>
               </a:rPr>
-              <a:t>Cite le(s) festival(s) trouvés dans la base </a:t>
+              <a:t>Cite-le(s) festival(s) trouvés dans la base </a:t>
             </a:r>
             <a:r>
               <a:rPr lang="fr-FR" i="1" dirty="0">
@@ -11904,7 +12125,7 @@
         <p:spPr>
           <a:xfrm>
             <a:off x="142875" y="950595"/>
-            <a:ext cx="11772034" cy="3308598"/>
+            <a:ext cx="11772034" cy="3293209"/>
           </a:xfrm>
           <a:prstGeom prst="rect">
             <a:avLst/>
@@ -11927,7 +12148,7 @@
             </a:r>
           </a:p>
           <a:p>
-            <a:endParaRPr lang="fr-FR" dirty="0"/>
+            <a:endParaRPr lang="fr-FR" sz="1000" dirty="0"/>
           </a:p>
           <a:p>
             <a:pPr marL="449263"/>
@@ -11957,8 +12178,8 @@
           </a:p>
           <a:p>
             <a:pPr marL="742950" lvl="1" indent="-285750">
-              <a:buFontTx/>
-              <a:buChar char="-"/>
+              <a:buFont typeface="Wingdings" panose="05000000000000000000" pitchFamily="2" charset="2"/>
+              <a:buChar char="à"/>
             </a:pPr>
             <a:r>
               <a:rPr lang="fr-FR" dirty="0">
@@ -11970,9 +12191,9 @@
             </a:r>
           </a:p>
           <a:p>
-            <a:pPr marL="742950" lvl="1" indent="-285750">
-              <a:buFontTx/>
-              <a:buChar char="-"/>
+            <a:pPr marL="1200150" lvl="2" indent="-285750">
+              <a:buFont typeface="Wingdings" panose="05000000000000000000" pitchFamily="2" charset="2"/>
+              <a:buChar char="à"/>
             </a:pPr>
             <a:r>
               <a:rPr lang="fr-FR" dirty="0">
@@ -11997,7 +12218,7 @@
             </a:r>
           </a:p>
           <a:p>
-            <a:endParaRPr lang="fr-FR" dirty="0">
+            <a:endParaRPr lang="fr-FR" sz="1000" dirty="0">
               <a:solidFill>
                 <a:schemeClr val="bg1"/>
               </a:solidFill>
@@ -12011,7 +12232,7 @@
                   <a:schemeClr val="bg1"/>
                 </a:solidFill>
               </a:rPr>
-              <a:t>Comment Interroger une base d’événements en langage naturel ?</a:t>
+              <a:t>Comment Interroger une base d’événements en langage naturel ? Ou plutôt, comment fournir aux utilisateurs une réponse claire à une question données ?</a:t>
             </a:r>
           </a:p>
         </p:txBody>
@@ -12895,7 +13116,7 @@
                   <a:schemeClr val="bg1"/>
                 </a:solidFill>
               </a:rPr>
-              <a:t>Produire une base technique reproductible b       </a:t>
+              <a:t>Produire une base technique reproductible       </a:t>
             </a:r>
           </a:p>
         </p:txBody>

</xml_diff>

<commit_message>
P11 - fix setup_rag_from_scratch.bat : ajout poetry/pipx au PATH + install Python 3.11
</commit_message>
<xml_diff>
--- a/P11_Categorisez_automatiquement_des_questions_aymeric_bailleul/_projet/_docs/ABAI_P11_02_presentation_20260216.pptx
+++ b/P11_Categorisez_automatiquement_des_questions_aymeric_bailleul/_projet/_docs/ABAI_P11_02_presentation_20260216.pptx
@@ -211,7 +211,7 @@
           <a:p>
             <a:fld id="{FC1C4A0D-7723-4A92-ABBB-96643D195969}" type="datetimeFigureOut">
               <a:rPr lang="fr-FR" smtClean="0"/>
-              <a:t>26/02/2026</a:t>
+              <a:t>02/03/2026</a:t>
             </a:fld>
             <a:endParaRPr lang="fr-FR"/>
           </a:p>
@@ -522,7 +522,18 @@
           <a:bodyPr/>
           <a:lstStyle/>
           <a:p>
-            <a:endParaRPr lang="fr-FR" dirty="0"/>
+            <a:r>
+              <a:rPr lang="fr-FR" dirty="0"/>
+              <a:t>Nous allons aborder aujourd'hui la conception d'un assistant conversationnel pour l'entreprise </a:t>
+            </a:r>
+            <a:r>
+              <a:rPr lang="fr-FR" dirty="0" err="1"/>
+              <a:t>Puls</a:t>
+            </a:r>
+            <a:r>
+              <a:rPr lang="fr-FR" dirty="0"/>
+              <a:t>-Events, dont l'objectif est de simplifier l'accès des utilisateurs aux données relatives aux événements culturels.</a:t>
+            </a:r>
           </a:p>
         </p:txBody>
       </p:sp>
@@ -760,8 +771,28 @@
                 <a:ea typeface="+mn-ea"/>
                 <a:cs typeface="+mn-cs"/>
               </a:rPr>
-              <a:t> : curseur pertinence/diversité du MMR (0 = tout diversifier, 1 = tout pertinent)</a:t>
-            </a:r>
+              <a:t> : curseur pertinence/diversité du MMR (0 = tout diversifier, 1 = tout pertinent) </a:t>
+            </a:r>
+            <a:r>
+              <a:rPr lang="fr-FR" sz="1200" i="1" dirty="0">
+                <a:solidFill>
+                  <a:schemeClr val="accent1">
+                    <a:lumMod val="40000"/>
+                    <a:lumOff val="60000"/>
+                  </a:schemeClr>
+                </a:solidFill>
+              </a:rPr>
+              <a:t>70% pertinence, 30% nouveauté</a:t>
+            </a:r>
+            <a:endParaRPr lang="fr-FR" sz="1200" b="0" i="0" kern="1200" dirty="0">
+              <a:solidFill>
+                <a:schemeClr val="tx1"/>
+              </a:solidFill>
+              <a:effectLst/>
+              <a:latin typeface="+mn-lt"/>
+              <a:ea typeface="+mn-ea"/>
+              <a:cs typeface="+mn-cs"/>
+            </a:endParaRPr>
           </a:p>
           <a:p>
             <a:r>
@@ -1696,6 +1727,1345 @@
         <p:txBody>
           <a:bodyPr/>
           <a:lstStyle/>
+          <a:p>
+            <a:r>
+              <a:rPr lang="fr-FR" sz="1200" b="0" kern="1200" dirty="0">
+                <a:solidFill>
+                  <a:schemeClr val="tx1"/>
+                </a:solidFill>
+                <a:effectLst/>
+                <a:latin typeface="+mn-lt"/>
+                <a:ea typeface="+mn-ea"/>
+                <a:cs typeface="+mn-cs"/>
+              </a:rPr>
+              <a:t>Comment </a:t>
+            </a:r>
+            <a:r>
+              <a:rPr lang="fr-FR" sz="1200" b="0" kern="1200" dirty="0" err="1">
+                <a:solidFill>
+                  <a:schemeClr val="tx1"/>
+                </a:solidFill>
+                <a:effectLst/>
+                <a:latin typeface="+mn-lt"/>
+                <a:ea typeface="+mn-ea"/>
+                <a:cs typeface="+mn-cs"/>
+              </a:rPr>
+              <a:t>Faiss</a:t>
+            </a:r>
+            <a:r>
+              <a:rPr lang="fr-FR" sz="1200" b="0" kern="1200" dirty="0">
+                <a:solidFill>
+                  <a:schemeClr val="tx1"/>
+                </a:solidFill>
+                <a:effectLst/>
+                <a:latin typeface="+mn-lt"/>
+                <a:ea typeface="+mn-ea"/>
+                <a:cs typeface="+mn-cs"/>
+              </a:rPr>
+              <a:t> optimise les recherches?</a:t>
+            </a:r>
+          </a:p>
+          <a:p>
+            <a:r>
+              <a:rPr lang="fr-FR" sz="1200" b="0" kern="1200" dirty="0">
+                <a:solidFill>
+                  <a:schemeClr val="tx1"/>
+                </a:solidFill>
+                <a:effectLst/>
+                <a:latin typeface="+mn-lt"/>
+                <a:ea typeface="+mn-ea"/>
+                <a:cs typeface="+mn-cs"/>
+              </a:rPr>
+              <a:t>  - </a:t>
+            </a:r>
+            <a:r>
+              <a:rPr lang="fr-FR" sz="1200" b="0" kern="1200" dirty="0" err="1">
+                <a:solidFill>
+                  <a:schemeClr val="tx1"/>
+                </a:solidFill>
+                <a:effectLst/>
+                <a:latin typeface="+mn-lt"/>
+                <a:ea typeface="+mn-ea"/>
+                <a:cs typeface="+mn-cs"/>
+              </a:rPr>
+              <a:t>IndexFlatIP</a:t>
+            </a:r>
+            <a:r>
+              <a:rPr lang="fr-FR" sz="1200" b="0" kern="1200" dirty="0">
+                <a:solidFill>
+                  <a:schemeClr val="tx1"/>
+                </a:solidFill>
+                <a:effectLst/>
+                <a:latin typeface="+mn-lt"/>
+                <a:ea typeface="+mn-ea"/>
+                <a:cs typeface="+mn-cs"/>
+              </a:rPr>
+              <a:t> calcule le produit scalaire entre la </a:t>
+            </a:r>
+            <a:r>
+              <a:rPr lang="fr-FR" sz="1200" b="0" kern="1200" dirty="0" err="1">
+                <a:solidFill>
+                  <a:schemeClr val="tx1"/>
+                </a:solidFill>
+                <a:effectLst/>
+                <a:latin typeface="+mn-lt"/>
+                <a:ea typeface="+mn-ea"/>
+                <a:cs typeface="+mn-cs"/>
+              </a:rPr>
+              <a:t>requete</a:t>
+            </a:r>
+            <a:r>
+              <a:rPr lang="fr-FR" sz="1200" b="0" kern="1200" dirty="0">
+                <a:solidFill>
+                  <a:schemeClr val="tx1"/>
+                </a:solidFill>
+                <a:effectLst/>
+                <a:latin typeface="+mn-lt"/>
+                <a:ea typeface="+mn-ea"/>
+                <a:cs typeface="+mn-cs"/>
+              </a:rPr>
+              <a:t> et les 10 363 vecteurs normalises (1024D). Equivalent a la </a:t>
+            </a:r>
+            <a:r>
+              <a:rPr lang="fr-FR" sz="1200" b="0" kern="1200" dirty="0" err="1">
+                <a:solidFill>
+                  <a:schemeClr val="tx1"/>
+                </a:solidFill>
+                <a:effectLst/>
+                <a:latin typeface="+mn-lt"/>
+                <a:ea typeface="+mn-ea"/>
+                <a:cs typeface="+mn-cs"/>
+              </a:rPr>
+              <a:t>similarite</a:t>
+            </a:r>
+            <a:r>
+              <a:rPr lang="fr-FR" sz="1200" b="0" kern="1200" dirty="0">
+                <a:solidFill>
+                  <a:schemeClr val="tx1"/>
+                </a:solidFill>
+                <a:effectLst/>
+                <a:latin typeface="+mn-lt"/>
+                <a:ea typeface="+mn-ea"/>
+                <a:cs typeface="+mn-cs"/>
+              </a:rPr>
+              <a:t> cosinus (donne la similarité de deux vecteurs à n dimensions en déterminant le cosinus de leur angle). </a:t>
+            </a:r>
+          </a:p>
+          <a:p>
+            <a:endParaRPr lang="fr-FR" sz="1200" b="0" kern="1200" dirty="0">
+              <a:solidFill>
+                <a:schemeClr val="tx1"/>
+              </a:solidFill>
+              <a:effectLst/>
+              <a:latin typeface="+mn-lt"/>
+              <a:ea typeface="+mn-ea"/>
+              <a:cs typeface="+mn-cs"/>
+            </a:endParaRPr>
+          </a:p>
+          <a:p>
+            <a:r>
+              <a:rPr lang="fr-FR" sz="1200" b="0" kern="1200" dirty="0">
+                <a:solidFill>
+                  <a:schemeClr val="tx1"/>
+                </a:solidFill>
+                <a:effectLst/>
+                <a:latin typeface="+mn-lt"/>
+                <a:ea typeface="+mn-ea"/>
+                <a:cs typeface="+mn-cs"/>
+              </a:rPr>
+              <a:t>Limitations de </a:t>
+            </a:r>
+            <a:r>
+              <a:rPr lang="fr-FR" sz="1200" b="0" kern="1200" dirty="0" err="1">
+                <a:solidFill>
+                  <a:schemeClr val="tx1"/>
+                </a:solidFill>
+                <a:effectLst/>
+                <a:latin typeface="+mn-lt"/>
+                <a:ea typeface="+mn-ea"/>
+                <a:cs typeface="+mn-cs"/>
+              </a:rPr>
+              <a:t>Faiss</a:t>
+            </a:r>
+            <a:r>
+              <a:rPr lang="fr-FR" sz="1200" b="0" kern="1200" dirty="0">
+                <a:solidFill>
+                  <a:schemeClr val="tx1"/>
+                </a:solidFill>
+                <a:effectLst/>
+                <a:latin typeface="+mn-lt"/>
+                <a:ea typeface="+mn-ea"/>
+                <a:cs typeface="+mn-cs"/>
+              </a:rPr>
+              <a:t> pour grandes </a:t>
+            </a:r>
+            <a:r>
+              <a:rPr lang="fr-FR" sz="1200" b="0" kern="1200" dirty="0" err="1">
+                <a:solidFill>
+                  <a:schemeClr val="tx1"/>
+                </a:solidFill>
+                <a:effectLst/>
+                <a:latin typeface="+mn-lt"/>
+                <a:ea typeface="+mn-ea"/>
+                <a:cs typeface="+mn-cs"/>
+              </a:rPr>
+              <a:t>quantites</a:t>
+            </a:r>
+            <a:r>
+              <a:rPr lang="fr-FR" sz="1200" b="0" kern="1200" dirty="0">
+                <a:solidFill>
+                  <a:schemeClr val="tx1"/>
+                </a:solidFill>
+                <a:effectLst/>
+                <a:latin typeface="+mn-lt"/>
+                <a:ea typeface="+mn-ea"/>
+                <a:cs typeface="+mn-cs"/>
+              </a:rPr>
+              <a:t>?</a:t>
+            </a:r>
+          </a:p>
+          <a:p>
+            <a:r>
+              <a:rPr lang="fr-FR" sz="1200" b="0" kern="1200" dirty="0">
+                <a:solidFill>
+                  <a:schemeClr val="tx1"/>
+                </a:solidFill>
+                <a:effectLst/>
+                <a:latin typeface="+mn-lt"/>
+                <a:ea typeface="+mn-ea"/>
+                <a:cs typeface="+mn-cs"/>
+              </a:rPr>
+              <a:t>  - Tout en RAM (41 MB pour 10k vecteurs -&gt; ~4 GB pour 1M). Recherche exhaustive O(n*d), non scalable. Pas de mise a jour </a:t>
+            </a:r>
+            <a:r>
+              <a:rPr lang="fr-FR" sz="1200" b="0" kern="1200" dirty="0" err="1">
+                <a:solidFill>
+                  <a:schemeClr val="tx1"/>
+                </a:solidFill>
+                <a:effectLst/>
+                <a:latin typeface="+mn-lt"/>
+                <a:ea typeface="+mn-ea"/>
+                <a:cs typeface="+mn-cs"/>
+              </a:rPr>
+              <a:t>incrementale</a:t>
+            </a:r>
+            <a:r>
+              <a:rPr lang="fr-FR" sz="1200" b="0" kern="1200" dirty="0">
+                <a:solidFill>
+                  <a:schemeClr val="tx1"/>
+                </a:solidFill>
+                <a:effectLst/>
+                <a:latin typeface="+mn-lt"/>
+                <a:ea typeface="+mn-ea"/>
+                <a:cs typeface="+mn-cs"/>
+              </a:rPr>
+              <a:t> (</a:t>
+            </a:r>
+            <a:r>
+              <a:rPr lang="fr-FR" sz="1200" b="0" kern="1200" dirty="0" err="1">
+                <a:solidFill>
+                  <a:schemeClr val="tx1"/>
+                </a:solidFill>
+                <a:effectLst/>
+                <a:latin typeface="+mn-lt"/>
+                <a:ea typeface="+mn-ea"/>
+                <a:cs typeface="+mn-cs"/>
+              </a:rPr>
+              <a:t>rebuild</a:t>
+            </a:r>
+            <a:r>
+              <a:rPr lang="fr-FR" sz="1200" b="0" kern="1200" dirty="0">
+                <a:solidFill>
+                  <a:schemeClr val="tx1"/>
+                </a:solidFill>
+                <a:effectLst/>
+                <a:latin typeface="+mn-lt"/>
+                <a:ea typeface="+mn-ea"/>
+                <a:cs typeface="+mn-cs"/>
+              </a:rPr>
+              <a:t> complet). Pas de filtrage natif par </a:t>
+            </a:r>
+            <a:r>
+              <a:rPr lang="fr-FR" sz="1200" b="0" kern="1200" dirty="0" err="1">
+                <a:solidFill>
+                  <a:schemeClr val="tx1"/>
+                </a:solidFill>
+                <a:effectLst/>
+                <a:latin typeface="+mn-lt"/>
+                <a:ea typeface="+mn-ea"/>
+                <a:cs typeface="+mn-cs"/>
+              </a:rPr>
+              <a:t>metadonnee</a:t>
+            </a:r>
+            <a:r>
+              <a:rPr lang="fr-FR" sz="1200" b="0" kern="1200" dirty="0">
+                <a:solidFill>
+                  <a:schemeClr val="tx1"/>
+                </a:solidFill>
+                <a:effectLst/>
+                <a:latin typeface="+mn-lt"/>
+                <a:ea typeface="+mn-ea"/>
+                <a:cs typeface="+mn-cs"/>
+              </a:rPr>
+              <a:t>. Solution production : </a:t>
+            </a:r>
+            <a:r>
+              <a:rPr lang="fr-FR" sz="1200" b="0" kern="1200" dirty="0" err="1">
+                <a:solidFill>
+                  <a:schemeClr val="tx1"/>
+                </a:solidFill>
+                <a:effectLst/>
+                <a:latin typeface="+mn-lt"/>
+                <a:ea typeface="+mn-ea"/>
+                <a:cs typeface="+mn-cs"/>
+              </a:rPr>
+              <a:t>Pinecone</a:t>
+            </a:r>
+            <a:r>
+              <a:rPr lang="fr-FR" sz="1200" b="0" kern="1200" dirty="0">
+                <a:solidFill>
+                  <a:schemeClr val="tx1"/>
+                </a:solidFill>
+                <a:effectLst/>
+                <a:latin typeface="+mn-lt"/>
+                <a:ea typeface="+mn-ea"/>
+                <a:cs typeface="+mn-cs"/>
+              </a:rPr>
+              <a:t>, </a:t>
+            </a:r>
+            <a:r>
+              <a:rPr lang="fr-FR" sz="1200" b="0" kern="1200" dirty="0" err="1">
+                <a:solidFill>
+                  <a:schemeClr val="tx1"/>
+                </a:solidFill>
+                <a:effectLst/>
+                <a:latin typeface="+mn-lt"/>
+                <a:ea typeface="+mn-ea"/>
+                <a:cs typeface="+mn-cs"/>
+              </a:rPr>
+              <a:t>Milvus</a:t>
+            </a:r>
+            <a:r>
+              <a:rPr lang="fr-FR" sz="1200" b="0" kern="1200" dirty="0">
+                <a:solidFill>
+                  <a:schemeClr val="tx1"/>
+                </a:solidFill>
+                <a:effectLst/>
+                <a:latin typeface="+mn-lt"/>
+                <a:ea typeface="+mn-ea"/>
+                <a:cs typeface="+mn-cs"/>
+              </a:rPr>
+              <a:t>, ou FAISS </a:t>
+            </a:r>
+            <a:r>
+              <a:rPr lang="fr-FR" sz="1200" b="0" kern="1200" dirty="0" err="1">
+                <a:solidFill>
+                  <a:schemeClr val="tx1"/>
+                </a:solidFill>
+                <a:effectLst/>
+                <a:latin typeface="+mn-lt"/>
+                <a:ea typeface="+mn-ea"/>
+                <a:cs typeface="+mn-cs"/>
+              </a:rPr>
+              <a:t>IVFFlat</a:t>
+            </a:r>
+            <a:r>
+              <a:rPr lang="fr-FR" sz="1200" b="0" kern="1200" dirty="0">
+                <a:solidFill>
+                  <a:schemeClr val="tx1"/>
+                </a:solidFill>
+                <a:effectLst/>
+                <a:latin typeface="+mn-lt"/>
+                <a:ea typeface="+mn-ea"/>
+                <a:cs typeface="+mn-cs"/>
+              </a:rPr>
+              <a:t>.</a:t>
+            </a:r>
+          </a:p>
+          <a:p>
+            <a:endParaRPr lang="fr-FR" sz="1200" b="0" kern="1200" dirty="0">
+              <a:solidFill>
+                <a:schemeClr val="tx1"/>
+              </a:solidFill>
+              <a:effectLst/>
+              <a:latin typeface="+mn-lt"/>
+              <a:ea typeface="+mn-ea"/>
+              <a:cs typeface="+mn-cs"/>
+            </a:endParaRPr>
+          </a:p>
+          <a:p>
+            <a:r>
+              <a:rPr lang="fr-FR" sz="1200" b="0" kern="1200" dirty="0">
+                <a:solidFill>
+                  <a:schemeClr val="tx1"/>
+                </a:solidFill>
+                <a:effectLst/>
+                <a:latin typeface="+mn-lt"/>
+                <a:ea typeface="+mn-ea"/>
+                <a:cs typeface="+mn-cs"/>
+              </a:rPr>
+              <a:t>Pourquoi choisir </a:t>
+            </a:r>
+            <a:r>
+              <a:rPr lang="fr-FR" sz="1200" b="0" kern="1200" dirty="0" err="1">
+                <a:solidFill>
+                  <a:schemeClr val="tx1"/>
+                </a:solidFill>
+                <a:effectLst/>
+                <a:latin typeface="+mn-lt"/>
+                <a:ea typeface="+mn-ea"/>
+                <a:cs typeface="+mn-cs"/>
+              </a:rPr>
+              <a:t>LangChain</a:t>
+            </a:r>
+            <a:r>
+              <a:rPr lang="fr-FR" sz="1200" b="0" kern="1200" dirty="0">
+                <a:solidFill>
+                  <a:schemeClr val="tx1"/>
+                </a:solidFill>
+                <a:effectLst/>
+                <a:latin typeface="+mn-lt"/>
+                <a:ea typeface="+mn-ea"/>
+                <a:cs typeface="+mn-cs"/>
+              </a:rPr>
+              <a:t>?</a:t>
+            </a:r>
+          </a:p>
+          <a:p>
+            <a:r>
+              <a:rPr lang="fr-FR" sz="1200" b="0" kern="1200" dirty="0">
+                <a:solidFill>
+                  <a:schemeClr val="tx1"/>
+                </a:solidFill>
+                <a:effectLst/>
+                <a:latin typeface="+mn-lt"/>
+                <a:ea typeface="+mn-ea"/>
+                <a:cs typeface="+mn-cs"/>
+              </a:rPr>
+              <a:t>  - Interface </a:t>
+            </a:r>
+            <a:r>
+              <a:rPr lang="fr-FR" sz="1200" b="0" kern="1200" dirty="0" err="1">
+                <a:solidFill>
+                  <a:schemeClr val="tx1"/>
+                </a:solidFill>
+                <a:effectLst/>
+                <a:latin typeface="+mn-lt"/>
+                <a:ea typeface="+mn-ea"/>
+                <a:cs typeface="+mn-cs"/>
+              </a:rPr>
+              <a:t>unifiee</a:t>
+            </a:r>
+            <a:r>
+              <a:rPr lang="fr-FR" sz="1200" b="0" kern="1200" dirty="0">
+                <a:solidFill>
+                  <a:schemeClr val="tx1"/>
+                </a:solidFill>
+                <a:effectLst/>
+                <a:latin typeface="+mn-lt"/>
+                <a:ea typeface="+mn-ea"/>
+                <a:cs typeface="+mn-cs"/>
+              </a:rPr>
+              <a:t> FAISS + Mistral LLM + </a:t>
+            </a:r>
+            <a:r>
+              <a:rPr lang="fr-FR" sz="1200" b="0" kern="1200" dirty="0" err="1">
+                <a:solidFill>
+                  <a:schemeClr val="tx1"/>
+                </a:solidFill>
+                <a:effectLst/>
+                <a:latin typeface="+mn-lt"/>
+                <a:ea typeface="+mn-ea"/>
+                <a:cs typeface="+mn-cs"/>
+              </a:rPr>
+              <a:t>Embeddings</a:t>
+            </a:r>
+            <a:r>
+              <a:rPr lang="fr-FR" sz="1200" b="0" kern="1200" dirty="0">
+                <a:solidFill>
+                  <a:schemeClr val="tx1"/>
+                </a:solidFill>
+                <a:effectLst/>
+                <a:latin typeface="+mn-lt"/>
+                <a:ea typeface="+mn-ea"/>
+                <a:cs typeface="+mn-cs"/>
+              </a:rPr>
+              <a:t>. Pipeline RAG </a:t>
+            </a:r>
+            <a:r>
+              <a:rPr lang="fr-FR" sz="1200" b="0" kern="1200" dirty="0" err="1">
+                <a:solidFill>
+                  <a:schemeClr val="tx1"/>
+                </a:solidFill>
+                <a:effectLst/>
+                <a:latin typeface="+mn-lt"/>
+                <a:ea typeface="+mn-ea"/>
+                <a:cs typeface="+mn-cs"/>
+              </a:rPr>
+              <a:t>declaratif</a:t>
+            </a:r>
+            <a:r>
+              <a:rPr lang="fr-FR" sz="1200" b="0" kern="1200" dirty="0">
+                <a:solidFill>
+                  <a:schemeClr val="tx1"/>
+                </a:solidFill>
+                <a:effectLst/>
+                <a:latin typeface="+mn-lt"/>
+                <a:ea typeface="+mn-ea"/>
+                <a:cs typeface="+mn-cs"/>
+              </a:rPr>
+              <a:t> avec l'operateur |. MMR </a:t>
+            </a:r>
+            <a:r>
+              <a:rPr lang="fr-FR" sz="1200" b="0" kern="1200" dirty="0" err="1">
+                <a:solidFill>
+                  <a:schemeClr val="tx1"/>
+                </a:solidFill>
+                <a:effectLst/>
+                <a:latin typeface="+mn-lt"/>
+                <a:ea typeface="+mn-ea"/>
+                <a:cs typeface="+mn-cs"/>
+              </a:rPr>
+              <a:t>integre</a:t>
+            </a:r>
+            <a:r>
+              <a:rPr lang="fr-FR" sz="1200" b="0" kern="1200" dirty="0">
+                <a:solidFill>
+                  <a:schemeClr val="tx1"/>
+                </a:solidFill>
+                <a:effectLst/>
+                <a:latin typeface="+mn-lt"/>
+                <a:ea typeface="+mn-ea"/>
+                <a:cs typeface="+mn-cs"/>
+              </a:rPr>
+              <a:t> pour </a:t>
+            </a:r>
+            <a:r>
+              <a:rPr lang="fr-FR" sz="1200" b="0" kern="1200" dirty="0" err="1">
+                <a:solidFill>
+                  <a:schemeClr val="tx1"/>
+                </a:solidFill>
+                <a:effectLst/>
+                <a:latin typeface="+mn-lt"/>
+                <a:ea typeface="+mn-ea"/>
+                <a:cs typeface="+mn-cs"/>
+              </a:rPr>
+              <a:t>reduire</a:t>
+            </a:r>
+            <a:r>
+              <a:rPr lang="fr-FR" sz="1200" b="0" kern="1200" dirty="0">
+                <a:solidFill>
+                  <a:schemeClr val="tx1"/>
+                </a:solidFill>
+                <a:effectLst/>
+                <a:latin typeface="+mn-lt"/>
+                <a:ea typeface="+mn-ea"/>
+                <a:cs typeface="+mn-cs"/>
+              </a:rPr>
+              <a:t> les </a:t>
+            </a:r>
+            <a:r>
+              <a:rPr lang="fr-FR" sz="1200" b="0" kern="1200" dirty="0" err="1">
+                <a:solidFill>
+                  <a:schemeClr val="tx1"/>
+                </a:solidFill>
+                <a:effectLst/>
+                <a:latin typeface="+mn-lt"/>
+                <a:ea typeface="+mn-ea"/>
+                <a:cs typeface="+mn-cs"/>
+              </a:rPr>
+              <a:t>chunks</a:t>
+            </a:r>
+            <a:r>
+              <a:rPr lang="fr-FR" sz="1200" b="0" kern="1200" dirty="0">
+                <a:solidFill>
+                  <a:schemeClr val="tx1"/>
+                </a:solidFill>
+                <a:effectLst/>
+                <a:latin typeface="+mn-lt"/>
+                <a:ea typeface="+mn-ea"/>
+                <a:cs typeface="+mn-cs"/>
+              </a:rPr>
+              <a:t> redondants. Facilite le changement de composants sans </a:t>
+            </a:r>
+            <a:r>
+              <a:rPr lang="fr-FR" sz="1200" b="0" kern="1200" dirty="0" err="1">
+                <a:solidFill>
+                  <a:schemeClr val="tx1"/>
+                </a:solidFill>
+                <a:effectLst/>
+                <a:latin typeface="+mn-lt"/>
+                <a:ea typeface="+mn-ea"/>
+                <a:cs typeface="+mn-cs"/>
+              </a:rPr>
+              <a:t>refactoring</a:t>
+            </a:r>
+            <a:r>
+              <a:rPr lang="fr-FR" sz="1200" b="0" kern="1200" dirty="0">
+                <a:solidFill>
+                  <a:schemeClr val="tx1"/>
+                </a:solidFill>
+                <a:effectLst/>
+                <a:latin typeface="+mn-lt"/>
+                <a:ea typeface="+mn-ea"/>
+                <a:cs typeface="+mn-cs"/>
+              </a:rPr>
+              <a:t>. </a:t>
+            </a:r>
+            <a:r>
+              <a:rPr lang="fr-FR" sz="1200" b="0" kern="1200" dirty="0" err="1">
+                <a:solidFill>
+                  <a:schemeClr val="tx1"/>
+                </a:solidFill>
+                <a:effectLst/>
+                <a:latin typeface="+mn-lt"/>
+                <a:ea typeface="+mn-ea"/>
+                <a:cs typeface="+mn-cs"/>
+              </a:rPr>
+              <a:t>Integration</a:t>
+            </a:r>
+            <a:r>
+              <a:rPr lang="fr-FR" sz="1200" b="0" kern="1200" dirty="0">
+                <a:solidFill>
+                  <a:schemeClr val="tx1"/>
+                </a:solidFill>
+                <a:effectLst/>
+                <a:latin typeface="+mn-lt"/>
+                <a:ea typeface="+mn-ea"/>
+                <a:cs typeface="+mn-cs"/>
+              </a:rPr>
+              <a:t> native Ragas (</a:t>
+            </a:r>
+            <a:r>
+              <a:rPr lang="fr-FR" sz="1200" b="0" kern="1200" dirty="0" err="1">
+                <a:solidFill>
+                  <a:schemeClr val="tx1"/>
+                </a:solidFill>
+                <a:effectLst/>
+                <a:latin typeface="+mn-lt"/>
+                <a:ea typeface="+mn-ea"/>
+                <a:cs typeface="+mn-cs"/>
+              </a:rPr>
+              <a:t>evaluation</a:t>
+            </a:r>
+            <a:r>
+              <a:rPr lang="fr-FR" sz="1200" b="0" kern="1200" dirty="0">
+                <a:solidFill>
+                  <a:schemeClr val="tx1"/>
+                </a:solidFill>
+                <a:effectLst/>
+                <a:latin typeface="+mn-lt"/>
+                <a:ea typeface="+mn-ea"/>
+                <a:cs typeface="+mn-cs"/>
+              </a:rPr>
+              <a:t>) et </a:t>
+            </a:r>
+            <a:r>
+              <a:rPr lang="fr-FR" sz="1200" b="0" kern="1200" dirty="0" err="1">
+                <a:solidFill>
+                  <a:schemeClr val="tx1"/>
+                </a:solidFill>
+                <a:effectLst/>
+                <a:latin typeface="+mn-lt"/>
+                <a:ea typeface="+mn-ea"/>
+                <a:cs typeface="+mn-cs"/>
+              </a:rPr>
+              <a:t>Streamlit</a:t>
+            </a:r>
+            <a:r>
+              <a:rPr lang="fr-FR" sz="1200" b="0" kern="1200" dirty="0">
+                <a:solidFill>
+                  <a:schemeClr val="tx1"/>
+                </a:solidFill>
+                <a:effectLst/>
+                <a:latin typeface="+mn-lt"/>
+                <a:ea typeface="+mn-ea"/>
+                <a:cs typeface="+mn-cs"/>
+              </a:rPr>
+              <a:t> (interface).</a:t>
+            </a:r>
+          </a:p>
+          <a:p>
+            <a:endParaRPr lang="fr-FR" sz="1200" b="0" kern="1200" dirty="0">
+              <a:solidFill>
+                <a:schemeClr val="tx1"/>
+              </a:solidFill>
+              <a:effectLst/>
+              <a:latin typeface="+mn-lt"/>
+              <a:ea typeface="+mn-ea"/>
+              <a:cs typeface="+mn-cs"/>
+            </a:endParaRPr>
+          </a:p>
+          <a:p>
+            <a:r>
+              <a:rPr lang="fr-FR" sz="1200" b="0" kern="1200" dirty="0" err="1">
+                <a:solidFill>
+                  <a:schemeClr val="tx1"/>
+                </a:solidFill>
+                <a:effectLst/>
+                <a:latin typeface="+mn-lt"/>
+                <a:ea typeface="+mn-ea"/>
+                <a:cs typeface="+mn-cs"/>
+              </a:rPr>
+              <a:t>Methodes</a:t>
+            </a:r>
+            <a:r>
+              <a:rPr lang="fr-FR" sz="1200" b="0" kern="1200" dirty="0">
+                <a:solidFill>
+                  <a:schemeClr val="tx1"/>
+                </a:solidFill>
+                <a:effectLst/>
+                <a:latin typeface="+mn-lt"/>
+                <a:ea typeface="+mn-ea"/>
+                <a:cs typeface="+mn-cs"/>
+              </a:rPr>
+              <a:t> de garantie de </a:t>
+            </a:r>
+            <a:r>
+              <a:rPr lang="fr-FR" sz="1200" b="0" kern="1200" dirty="0" err="1">
+                <a:solidFill>
+                  <a:schemeClr val="tx1"/>
+                </a:solidFill>
+                <a:effectLst/>
+                <a:latin typeface="+mn-lt"/>
+                <a:ea typeface="+mn-ea"/>
+                <a:cs typeface="+mn-cs"/>
+              </a:rPr>
+              <a:t>qualite</a:t>
+            </a:r>
+            <a:r>
+              <a:rPr lang="fr-FR" sz="1200" b="0" kern="1200" dirty="0">
+                <a:solidFill>
+                  <a:schemeClr val="tx1"/>
+                </a:solidFill>
+                <a:effectLst/>
+                <a:latin typeface="+mn-lt"/>
+                <a:ea typeface="+mn-ea"/>
+                <a:cs typeface="+mn-cs"/>
+              </a:rPr>
+              <a:t> des </a:t>
+            </a:r>
+            <a:r>
+              <a:rPr lang="fr-FR" sz="1200" b="0" kern="1200" dirty="0" err="1">
+                <a:solidFill>
+                  <a:schemeClr val="tx1"/>
+                </a:solidFill>
+                <a:effectLst/>
+                <a:latin typeface="+mn-lt"/>
+                <a:ea typeface="+mn-ea"/>
+                <a:cs typeface="+mn-cs"/>
+              </a:rPr>
+              <a:t>donnees</a:t>
+            </a:r>
+            <a:r>
+              <a:rPr lang="fr-FR" sz="1200" b="0" kern="1200" dirty="0">
+                <a:solidFill>
+                  <a:schemeClr val="tx1"/>
+                </a:solidFill>
+                <a:effectLst/>
+                <a:latin typeface="+mn-lt"/>
+                <a:ea typeface="+mn-ea"/>
+                <a:cs typeface="+mn-cs"/>
+              </a:rPr>
+              <a:t>?</a:t>
+            </a:r>
+          </a:p>
+          <a:p>
+            <a:r>
+              <a:rPr lang="fr-FR" sz="1200" b="0" kern="1200" dirty="0">
+                <a:solidFill>
+                  <a:schemeClr val="tx1"/>
+                </a:solidFill>
+                <a:effectLst/>
+                <a:latin typeface="+mn-lt"/>
+                <a:ea typeface="+mn-ea"/>
+                <a:cs typeface="+mn-cs"/>
+              </a:rPr>
+              <a:t>  - Filtrage </a:t>
+            </a:r>
+            <a:r>
+              <a:rPr lang="fr-FR" sz="1200" b="0" kern="1200" dirty="0" err="1">
+                <a:solidFill>
+                  <a:schemeClr val="tx1"/>
+                </a:solidFill>
+                <a:effectLst/>
+                <a:latin typeface="+mn-lt"/>
+                <a:ea typeface="+mn-ea"/>
+                <a:cs typeface="+mn-cs"/>
+              </a:rPr>
+              <a:t>geographique</a:t>
+            </a:r>
+            <a:r>
+              <a:rPr lang="fr-FR" sz="1200" b="0" kern="1200" dirty="0">
+                <a:solidFill>
+                  <a:schemeClr val="tx1"/>
+                </a:solidFill>
+                <a:effectLst/>
+                <a:latin typeface="+mn-lt"/>
+                <a:ea typeface="+mn-ea"/>
+                <a:cs typeface="+mn-cs"/>
+              </a:rPr>
+              <a:t> (13 </a:t>
+            </a:r>
+            <a:r>
+              <a:rPr lang="fr-FR" sz="1200" b="0" kern="1200" dirty="0" err="1">
+                <a:solidFill>
+                  <a:schemeClr val="tx1"/>
+                </a:solidFill>
+                <a:effectLst/>
+                <a:latin typeface="+mn-lt"/>
+                <a:ea typeface="+mn-ea"/>
+                <a:cs typeface="+mn-cs"/>
+              </a:rPr>
+              <a:t>departements</a:t>
+            </a:r>
+            <a:r>
+              <a:rPr lang="fr-FR" sz="1200" b="0" kern="1200" dirty="0">
+                <a:solidFill>
+                  <a:schemeClr val="tx1"/>
+                </a:solidFill>
+                <a:effectLst/>
+                <a:latin typeface="+mn-lt"/>
+                <a:ea typeface="+mn-ea"/>
+                <a:cs typeface="+mn-cs"/>
+              </a:rPr>
+              <a:t> Occitanie) et temporel (1 an). Nettoyage HTML + </a:t>
+            </a:r>
+            <a:r>
+              <a:rPr lang="fr-FR" sz="1200" b="0" kern="1200" dirty="0" err="1">
+                <a:solidFill>
+                  <a:schemeClr val="tx1"/>
+                </a:solidFill>
+                <a:effectLst/>
+                <a:latin typeface="+mn-lt"/>
+                <a:ea typeface="+mn-ea"/>
+                <a:cs typeface="+mn-cs"/>
+              </a:rPr>
+              <a:t>deduplication</a:t>
+            </a:r>
+            <a:r>
+              <a:rPr lang="fr-FR" sz="1200" b="0" kern="1200" dirty="0">
+                <a:solidFill>
+                  <a:schemeClr val="tx1"/>
+                </a:solidFill>
+                <a:effectLst/>
+                <a:latin typeface="+mn-lt"/>
+                <a:ea typeface="+mn-ea"/>
+                <a:cs typeface="+mn-cs"/>
+              </a:rPr>
+              <a:t> par UID. </a:t>
+            </a:r>
+            <a:r>
+              <a:rPr lang="fr-FR" sz="1200" b="0" kern="1200" dirty="0" err="1">
+                <a:solidFill>
+                  <a:schemeClr val="tx1"/>
+                </a:solidFill>
+                <a:effectLst/>
+                <a:latin typeface="+mn-lt"/>
+                <a:ea typeface="+mn-ea"/>
+                <a:cs typeface="+mn-cs"/>
+              </a:rPr>
+              <a:t>Verification</a:t>
+            </a:r>
+            <a:r>
+              <a:rPr lang="fr-FR" sz="1200" b="0" kern="1200" dirty="0">
+                <a:solidFill>
+                  <a:schemeClr val="tx1"/>
+                </a:solidFill>
+                <a:effectLst/>
+                <a:latin typeface="+mn-lt"/>
+                <a:ea typeface="+mn-ea"/>
+                <a:cs typeface="+mn-cs"/>
+              </a:rPr>
+              <a:t> normes </a:t>
+            </a:r>
+            <a:r>
+              <a:rPr lang="fr-FR" sz="1200" b="0" kern="1200" dirty="0" err="1">
+                <a:solidFill>
+                  <a:schemeClr val="tx1"/>
+                </a:solidFill>
+                <a:effectLst/>
+                <a:latin typeface="+mn-lt"/>
+                <a:ea typeface="+mn-ea"/>
+                <a:cs typeface="+mn-cs"/>
+              </a:rPr>
+              <a:t>embeddings</a:t>
+            </a:r>
+            <a:r>
+              <a:rPr lang="fr-FR" sz="1200" b="0" kern="1200" dirty="0">
+                <a:solidFill>
+                  <a:schemeClr val="tx1"/>
+                </a:solidFill>
+                <a:effectLst/>
+                <a:latin typeface="+mn-lt"/>
+                <a:ea typeface="+mn-ea"/>
+                <a:cs typeface="+mn-cs"/>
+              </a:rPr>
+              <a:t> (= 1.0, pas de NaN). 120 tests </a:t>
+            </a:r>
+            <a:r>
+              <a:rPr lang="fr-FR" sz="1200" b="0" kern="1200" dirty="0" err="1">
+                <a:solidFill>
+                  <a:schemeClr val="tx1"/>
+                </a:solidFill>
+                <a:effectLst/>
+                <a:latin typeface="+mn-lt"/>
+                <a:ea typeface="+mn-ea"/>
+                <a:cs typeface="+mn-cs"/>
+              </a:rPr>
+              <a:t>pytest</a:t>
+            </a:r>
+            <a:r>
+              <a:rPr lang="fr-FR" sz="1200" b="0" kern="1200" dirty="0">
+                <a:solidFill>
+                  <a:schemeClr val="tx1"/>
+                </a:solidFill>
+                <a:effectLst/>
+                <a:latin typeface="+mn-lt"/>
+                <a:ea typeface="+mn-ea"/>
+                <a:cs typeface="+mn-cs"/>
+              </a:rPr>
+              <a:t> unitaires et d'</a:t>
+            </a:r>
+            <a:r>
+              <a:rPr lang="fr-FR" sz="1200" b="0" kern="1200" dirty="0" err="1">
+                <a:solidFill>
+                  <a:schemeClr val="tx1"/>
+                </a:solidFill>
+                <a:effectLst/>
+                <a:latin typeface="+mn-lt"/>
+                <a:ea typeface="+mn-ea"/>
+                <a:cs typeface="+mn-cs"/>
+              </a:rPr>
+              <a:t>integration</a:t>
+            </a:r>
+            <a:r>
+              <a:rPr lang="fr-FR" sz="1200" b="0" kern="1200" dirty="0">
+                <a:solidFill>
+                  <a:schemeClr val="tx1"/>
+                </a:solidFill>
+                <a:effectLst/>
+                <a:latin typeface="+mn-lt"/>
+                <a:ea typeface="+mn-ea"/>
+                <a:cs typeface="+mn-cs"/>
+              </a:rPr>
+              <a:t>. Evaluation Ragas sur 5 questions </a:t>
+            </a:r>
+            <a:r>
+              <a:rPr lang="fr-FR" sz="1200" b="0" kern="1200" dirty="0" err="1">
+                <a:solidFill>
+                  <a:schemeClr val="tx1"/>
+                </a:solidFill>
+                <a:effectLst/>
+                <a:latin typeface="+mn-lt"/>
+                <a:ea typeface="+mn-ea"/>
+                <a:cs typeface="+mn-cs"/>
+              </a:rPr>
+              <a:t>representatives</a:t>
+            </a:r>
+            <a:r>
+              <a:rPr lang="fr-FR" sz="1200" b="0" kern="1200" dirty="0">
+                <a:solidFill>
+                  <a:schemeClr val="tx1"/>
+                </a:solidFill>
+                <a:effectLst/>
+                <a:latin typeface="+mn-lt"/>
+                <a:ea typeface="+mn-ea"/>
+                <a:cs typeface="+mn-cs"/>
+              </a:rPr>
+              <a:t>.</a:t>
+            </a:r>
+          </a:p>
+          <a:p>
+            <a:endParaRPr lang="fr-FR" sz="1200" b="0" kern="1200" dirty="0">
+              <a:solidFill>
+                <a:schemeClr val="tx1"/>
+              </a:solidFill>
+              <a:effectLst/>
+              <a:latin typeface="+mn-lt"/>
+              <a:ea typeface="+mn-ea"/>
+              <a:cs typeface="+mn-cs"/>
+            </a:endParaRPr>
+          </a:p>
+          <a:p>
+            <a:r>
+              <a:rPr lang="fr-FR" sz="1200" b="0" kern="1200" dirty="0">
+                <a:solidFill>
+                  <a:schemeClr val="tx1"/>
+                </a:solidFill>
+                <a:effectLst/>
+                <a:latin typeface="+mn-lt"/>
+                <a:ea typeface="+mn-ea"/>
+                <a:cs typeface="+mn-cs"/>
+              </a:rPr>
+              <a:t>Comment </a:t>
+            </a:r>
+            <a:r>
+              <a:rPr lang="fr-FR" sz="1200" b="0" kern="1200" dirty="0" err="1">
+                <a:solidFill>
+                  <a:schemeClr val="tx1"/>
+                </a:solidFill>
+                <a:effectLst/>
+                <a:latin typeface="+mn-lt"/>
+                <a:ea typeface="+mn-ea"/>
+                <a:cs typeface="+mn-cs"/>
+              </a:rPr>
+              <a:t>detecter</a:t>
+            </a:r>
+            <a:r>
+              <a:rPr lang="fr-FR" sz="1200" b="0" kern="1200" dirty="0">
+                <a:solidFill>
+                  <a:schemeClr val="tx1"/>
+                </a:solidFill>
+                <a:effectLst/>
+                <a:latin typeface="+mn-lt"/>
+                <a:ea typeface="+mn-ea"/>
+                <a:cs typeface="+mn-cs"/>
+              </a:rPr>
+              <a:t> les </a:t>
+            </a:r>
+            <a:r>
+              <a:rPr lang="fr-FR" sz="1200" b="0" kern="1200" dirty="0" err="1">
+                <a:solidFill>
+                  <a:schemeClr val="tx1"/>
+                </a:solidFill>
+                <a:effectLst/>
+                <a:latin typeface="+mn-lt"/>
+                <a:ea typeface="+mn-ea"/>
+                <a:cs typeface="+mn-cs"/>
+              </a:rPr>
+              <a:t>derives</a:t>
+            </a:r>
+            <a:r>
+              <a:rPr lang="fr-FR" sz="1200" b="0" kern="1200" dirty="0">
+                <a:solidFill>
+                  <a:schemeClr val="tx1"/>
+                </a:solidFill>
+                <a:effectLst/>
+                <a:latin typeface="+mn-lt"/>
+                <a:ea typeface="+mn-ea"/>
+                <a:cs typeface="+mn-cs"/>
+              </a:rPr>
+              <a:t> de performance?</a:t>
+            </a:r>
+          </a:p>
+          <a:p>
+            <a:r>
+              <a:rPr lang="fr-FR" sz="1200" b="0" kern="1200" dirty="0">
+                <a:solidFill>
+                  <a:schemeClr val="tx1"/>
+                </a:solidFill>
+                <a:effectLst/>
+                <a:latin typeface="+mn-lt"/>
+                <a:ea typeface="+mn-ea"/>
+                <a:cs typeface="+mn-cs"/>
+              </a:rPr>
+              <a:t>  - Surveiller la baisse des scores de </a:t>
+            </a:r>
+            <a:r>
+              <a:rPr lang="fr-FR" sz="1200" b="0" kern="1200" dirty="0" err="1">
+                <a:solidFill>
+                  <a:schemeClr val="tx1"/>
+                </a:solidFill>
+                <a:effectLst/>
+                <a:latin typeface="+mn-lt"/>
+                <a:ea typeface="+mn-ea"/>
+                <a:cs typeface="+mn-cs"/>
+              </a:rPr>
+              <a:t>similarite</a:t>
+            </a:r>
+            <a:r>
+              <a:rPr lang="fr-FR" sz="1200" b="0" kern="1200" dirty="0">
+                <a:solidFill>
+                  <a:schemeClr val="tx1"/>
+                </a:solidFill>
+                <a:effectLst/>
+                <a:latin typeface="+mn-lt"/>
+                <a:ea typeface="+mn-ea"/>
+                <a:cs typeface="+mn-cs"/>
+              </a:rPr>
+              <a:t> FAISS (data drift) et des </a:t>
+            </a:r>
+            <a:r>
+              <a:rPr lang="fr-FR" sz="1200" b="0" kern="1200" dirty="0" err="1">
+                <a:solidFill>
+                  <a:schemeClr val="tx1"/>
+                </a:solidFill>
+                <a:effectLst/>
+                <a:latin typeface="+mn-lt"/>
+                <a:ea typeface="+mn-ea"/>
+                <a:cs typeface="+mn-cs"/>
+              </a:rPr>
+              <a:t>metriques</a:t>
+            </a:r>
+            <a:r>
+              <a:rPr lang="fr-FR" sz="1200" b="0" kern="1200" dirty="0">
+                <a:solidFill>
+                  <a:schemeClr val="tx1"/>
+                </a:solidFill>
+                <a:effectLst/>
+                <a:latin typeface="+mn-lt"/>
+                <a:ea typeface="+mn-ea"/>
+                <a:cs typeface="+mn-cs"/>
+              </a:rPr>
+              <a:t> Ragas vs </a:t>
+            </a:r>
+            <a:r>
+              <a:rPr lang="fr-FR" sz="1200" b="0" kern="1200" dirty="0" err="1">
+                <a:solidFill>
+                  <a:schemeClr val="tx1"/>
+                </a:solidFill>
+                <a:effectLst/>
+                <a:latin typeface="+mn-lt"/>
+                <a:ea typeface="+mn-ea"/>
+                <a:cs typeface="+mn-cs"/>
+              </a:rPr>
+              <a:t>baseline</a:t>
+            </a:r>
+            <a:r>
+              <a:rPr lang="fr-FR" sz="1200" b="0" kern="1200" dirty="0">
+                <a:solidFill>
+                  <a:schemeClr val="tx1"/>
+                </a:solidFill>
+                <a:effectLst/>
+                <a:latin typeface="+mn-lt"/>
+                <a:ea typeface="+mn-ea"/>
+                <a:cs typeface="+mn-cs"/>
+              </a:rPr>
+              <a:t> (0.73 / 0.91 / 0.68 / 0.65). Rejouer evaluate_rag.py </a:t>
+            </a:r>
+            <a:r>
+              <a:rPr lang="fr-FR" sz="1200" b="0" kern="1200" dirty="0" err="1">
+                <a:solidFill>
+                  <a:schemeClr val="tx1"/>
+                </a:solidFill>
+                <a:effectLst/>
+                <a:latin typeface="+mn-lt"/>
+                <a:ea typeface="+mn-ea"/>
+                <a:cs typeface="+mn-cs"/>
+              </a:rPr>
+              <a:t>periodiquement</a:t>
+            </a:r>
+            <a:r>
+              <a:rPr lang="fr-FR" sz="1200" b="0" kern="1200" dirty="0">
+                <a:solidFill>
+                  <a:schemeClr val="tx1"/>
+                </a:solidFill>
+                <a:effectLst/>
+                <a:latin typeface="+mn-lt"/>
+                <a:ea typeface="+mn-ea"/>
+                <a:cs typeface="+mn-cs"/>
+              </a:rPr>
+              <a:t>. Alerte si chute &gt; 10%. Feedback utilisateur dans </a:t>
+            </a:r>
+            <a:r>
+              <a:rPr lang="fr-FR" sz="1200" b="0" kern="1200" dirty="0" err="1">
+                <a:solidFill>
+                  <a:schemeClr val="tx1"/>
+                </a:solidFill>
+                <a:effectLst/>
+                <a:latin typeface="+mn-lt"/>
+                <a:ea typeface="+mn-ea"/>
+                <a:cs typeface="+mn-cs"/>
+              </a:rPr>
+              <a:t>Streamlit</a:t>
+            </a:r>
+            <a:r>
+              <a:rPr lang="fr-FR" sz="1200" b="0" kern="1200" dirty="0">
+                <a:solidFill>
+                  <a:schemeClr val="tx1"/>
+                </a:solidFill>
+                <a:effectLst/>
+                <a:latin typeface="+mn-lt"/>
+                <a:ea typeface="+mn-ea"/>
+                <a:cs typeface="+mn-cs"/>
+              </a:rPr>
+              <a:t>.</a:t>
+            </a:r>
+          </a:p>
+          <a:p>
+            <a:endParaRPr lang="fr-FR" sz="1200" b="0" kern="1200" dirty="0">
+              <a:solidFill>
+                <a:schemeClr val="tx1"/>
+              </a:solidFill>
+              <a:effectLst/>
+              <a:latin typeface="+mn-lt"/>
+              <a:ea typeface="+mn-ea"/>
+              <a:cs typeface="+mn-cs"/>
+            </a:endParaRPr>
+          </a:p>
+          <a:p>
+            <a:r>
+              <a:rPr lang="fr-FR" sz="1200" b="0" kern="1200" dirty="0">
+                <a:solidFill>
+                  <a:schemeClr val="tx1"/>
+                </a:solidFill>
+                <a:effectLst/>
+                <a:latin typeface="+mn-lt"/>
+                <a:ea typeface="+mn-ea"/>
+                <a:cs typeface="+mn-cs"/>
+              </a:rPr>
+              <a:t>Indicateurs de performance en production?</a:t>
+            </a:r>
+          </a:p>
+          <a:p>
+            <a:r>
+              <a:rPr lang="fr-FR" sz="1200" b="0" kern="1200" dirty="0">
+                <a:solidFill>
+                  <a:schemeClr val="tx1"/>
+                </a:solidFill>
+                <a:effectLst/>
+                <a:latin typeface="+mn-lt"/>
+                <a:ea typeface="+mn-ea"/>
+                <a:cs typeface="+mn-cs"/>
+              </a:rPr>
+              <a:t>  - Latence FAISS &lt; 100ms, </a:t>
+            </a:r>
+            <a:r>
+              <a:rPr lang="fr-FR" sz="1200" b="0" kern="1200" dirty="0" err="1">
+                <a:solidFill>
+                  <a:schemeClr val="tx1"/>
+                </a:solidFill>
+                <a:effectLst/>
+                <a:latin typeface="+mn-lt"/>
+                <a:ea typeface="+mn-ea"/>
+                <a:cs typeface="+mn-cs"/>
+              </a:rPr>
+              <a:t>reponse</a:t>
+            </a:r>
+            <a:r>
+              <a:rPr lang="fr-FR" sz="1200" b="0" kern="1200" dirty="0">
+                <a:solidFill>
+                  <a:schemeClr val="tx1"/>
+                </a:solidFill>
+                <a:effectLst/>
+                <a:latin typeface="+mn-lt"/>
+                <a:ea typeface="+mn-ea"/>
+                <a:cs typeface="+mn-cs"/>
+              </a:rPr>
+              <a:t> LLM &lt; 5s. </a:t>
+            </a:r>
+            <a:r>
+              <a:rPr lang="fr-FR" sz="1200" b="0" kern="1200" dirty="0" err="1">
+                <a:solidFill>
+                  <a:schemeClr val="tx1"/>
+                </a:solidFill>
+                <a:effectLst/>
+                <a:latin typeface="+mn-lt"/>
+                <a:ea typeface="+mn-ea"/>
+                <a:cs typeface="+mn-cs"/>
+              </a:rPr>
+              <a:t>Metriques</a:t>
+            </a:r>
+            <a:r>
+              <a:rPr lang="fr-FR" sz="1200" b="0" kern="1200" dirty="0">
+                <a:solidFill>
+                  <a:schemeClr val="tx1"/>
+                </a:solidFill>
+                <a:effectLst/>
+                <a:latin typeface="+mn-lt"/>
+                <a:ea typeface="+mn-ea"/>
+                <a:cs typeface="+mn-cs"/>
+              </a:rPr>
+              <a:t> Ragas : </a:t>
+            </a:r>
+            <a:r>
+              <a:rPr lang="fr-FR" sz="1200" b="0" kern="1200" dirty="0" err="1">
+                <a:solidFill>
+                  <a:schemeClr val="tx1"/>
+                </a:solidFill>
+                <a:effectLst/>
+                <a:latin typeface="+mn-lt"/>
+                <a:ea typeface="+mn-ea"/>
+                <a:cs typeface="+mn-cs"/>
+              </a:rPr>
+              <a:t>faithfulness</a:t>
+            </a:r>
+            <a:r>
+              <a:rPr lang="fr-FR" sz="1200" b="0" kern="1200" dirty="0">
+                <a:solidFill>
+                  <a:schemeClr val="tx1"/>
+                </a:solidFill>
+                <a:effectLst/>
+                <a:latin typeface="+mn-lt"/>
+                <a:ea typeface="+mn-ea"/>
+                <a:cs typeface="+mn-cs"/>
+              </a:rPr>
+              <a:t> &gt;= 0.65, </a:t>
+            </a:r>
+            <a:r>
+              <a:rPr lang="fr-FR" sz="1200" b="0" kern="1200" dirty="0" err="1">
+                <a:solidFill>
+                  <a:schemeClr val="tx1"/>
+                </a:solidFill>
+                <a:effectLst/>
+                <a:latin typeface="+mn-lt"/>
+                <a:ea typeface="+mn-ea"/>
+                <a:cs typeface="+mn-cs"/>
+              </a:rPr>
+              <a:t>answer_relevancy</a:t>
+            </a:r>
+            <a:r>
+              <a:rPr lang="fr-FR" sz="1200" b="0" kern="1200" dirty="0">
+                <a:solidFill>
+                  <a:schemeClr val="tx1"/>
+                </a:solidFill>
+                <a:effectLst/>
+                <a:latin typeface="+mn-lt"/>
+                <a:ea typeface="+mn-ea"/>
+                <a:cs typeface="+mn-cs"/>
+              </a:rPr>
+              <a:t> &gt;= 0.80. Taux d'erreur API &lt; 1%. Taux de satisfaction utilisateur. Couverture temporelle de l'index (</a:t>
+            </a:r>
+            <a:r>
+              <a:rPr lang="fr-FR" sz="1200" b="0" kern="1200" dirty="0" err="1">
+                <a:solidFill>
+                  <a:schemeClr val="tx1"/>
+                </a:solidFill>
+                <a:effectLst/>
+                <a:latin typeface="+mn-lt"/>
+                <a:ea typeface="+mn-ea"/>
+                <a:cs typeface="+mn-cs"/>
+              </a:rPr>
+              <a:t>declencheur</a:t>
+            </a:r>
+            <a:r>
+              <a:rPr lang="fr-FR" sz="1200" b="0" kern="1200" dirty="0">
+                <a:solidFill>
+                  <a:schemeClr val="tx1"/>
+                </a:solidFill>
+                <a:effectLst/>
+                <a:latin typeface="+mn-lt"/>
+                <a:ea typeface="+mn-ea"/>
+                <a:cs typeface="+mn-cs"/>
+              </a:rPr>
+              <a:t> de </a:t>
+            </a:r>
+            <a:r>
+              <a:rPr lang="fr-FR" sz="1200" b="0" kern="1200" dirty="0" err="1">
+                <a:solidFill>
+                  <a:schemeClr val="tx1"/>
+                </a:solidFill>
+                <a:effectLst/>
+                <a:latin typeface="+mn-lt"/>
+                <a:ea typeface="+mn-ea"/>
+                <a:cs typeface="+mn-cs"/>
+              </a:rPr>
+              <a:t>rebuild</a:t>
+            </a:r>
+            <a:r>
+              <a:rPr lang="fr-FR" sz="1200" b="0" kern="1200" dirty="0">
+                <a:solidFill>
+                  <a:schemeClr val="tx1"/>
+                </a:solidFill>
+                <a:effectLst/>
+                <a:latin typeface="+mn-lt"/>
+                <a:ea typeface="+mn-ea"/>
+                <a:cs typeface="+mn-cs"/>
+              </a:rPr>
+              <a:t> hebdomadaire).</a:t>
+            </a:r>
+          </a:p>
           <a:p>
             <a:pPr algn="l"/>
             <a:endParaRPr lang="fr-FR" sz="1200" b="0" kern="1200" dirty="0">
@@ -1986,7 +3356,7 @@
                   <a:schemeClr val="bg1"/>
                 </a:solidFill>
               </a:rPr>
-              <a:t> Ragas </a:t>
+              <a:t> Ragas via 4 métriques </a:t>
             </a:r>
             <a:r>
               <a:rPr lang="fr-FR" sz="800" b="0" i="0" u="none" dirty="0">
@@ -2982,6 +4352,86 @@
               <a:tabLst/>
               <a:defRPr/>
             </a:pPr>
+            <a:endParaRPr lang="fr-FR" sz="1200" b="0" kern="1200" dirty="0">
+              <a:solidFill>
+                <a:schemeClr val="tx1"/>
+              </a:solidFill>
+              <a:effectLst/>
+              <a:latin typeface="+mn-lt"/>
+              <a:ea typeface="+mn-ea"/>
+              <a:cs typeface="+mn-cs"/>
+            </a:endParaRPr>
+          </a:p>
+          <a:p>
+            <a:pPr marL="0" marR="0" lvl="0" indent="0" algn="l" defTabSz="914400" rtl="0" eaLnBrk="1" fontAlgn="auto" latinLnBrk="0" hangingPunct="1">
+              <a:lnSpc>
+                <a:spcPct val="100000"/>
+              </a:lnSpc>
+              <a:spcBef>
+                <a:spcPts val="0"/>
+              </a:spcBef>
+              <a:spcAft>
+                <a:spcPts val="0"/>
+              </a:spcAft>
+              <a:buClrTx/>
+              <a:buSzTx/>
+              <a:buFontTx/>
+              <a:buNone/>
+              <a:tabLst/>
+              <a:defRPr/>
+            </a:pPr>
+            <a:r>
+              <a:rPr lang="fr-FR" sz="1200" b="0" i="0" kern="1200" dirty="0" err="1">
+                <a:solidFill>
+                  <a:schemeClr val="tx1"/>
+                </a:solidFill>
+                <a:effectLst/>
+                <a:latin typeface="+mn-lt"/>
+                <a:ea typeface="+mn-ea"/>
+                <a:cs typeface="+mn-cs"/>
+              </a:rPr>
+              <a:t>LangChain</a:t>
+            </a:r>
+            <a:r>
+              <a:rPr lang="fr-FR" sz="1200" b="0" i="0" kern="1200" dirty="0">
+                <a:solidFill>
+                  <a:schemeClr val="tx1"/>
+                </a:solidFill>
+                <a:effectLst/>
+                <a:latin typeface="+mn-lt"/>
+                <a:ea typeface="+mn-ea"/>
+                <a:cs typeface="+mn-cs"/>
+              </a:rPr>
+              <a:t> permet d'intégrer des fonctionnalités de gestion de la mémoire à leurs systèmes . Il prend en charge : des systèmes de mémoire simples qui rappellent les conversations les plus récentes ; des structures de mémoire complexes qui analysent l'historique des messages pour fournir les résultats les plus pertinents.</a:t>
+            </a:r>
+            <a:endParaRPr lang="fr-FR" sz="1200" b="0" kern="1200" dirty="0">
+              <a:solidFill>
+                <a:schemeClr val="tx1"/>
+              </a:solidFill>
+              <a:effectLst/>
+              <a:latin typeface="+mn-lt"/>
+              <a:ea typeface="+mn-ea"/>
+              <a:cs typeface="+mn-cs"/>
+            </a:endParaRPr>
+          </a:p>
+          <a:p>
+            <a:pPr marL="0" marR="0" lvl="0" indent="0" algn="l" defTabSz="914400" rtl="0" eaLnBrk="1" fontAlgn="auto" latinLnBrk="0" hangingPunct="1">
+              <a:lnSpc>
+                <a:spcPct val="100000"/>
+              </a:lnSpc>
+              <a:spcBef>
+                <a:spcPts val="0"/>
+              </a:spcBef>
+              <a:spcAft>
+                <a:spcPts val="0"/>
+              </a:spcAft>
+              <a:buClrTx/>
+              <a:buSzTx/>
+              <a:buFontTx/>
+              <a:buNone/>
+              <a:tabLst/>
+              <a:defRPr/>
+            </a:pPr>
             <a:endParaRPr lang="fr-FR" sz="1700" b="0" dirty="0">
               <a:solidFill>
                 <a:srgbClr val="4CAF50"/>
@@ -3128,7 +4578,164 @@
                 <a:ea typeface="+mn-ea"/>
                 <a:cs typeface="+mn-cs"/>
               </a:rPr>
-              <a:t>FAISS (développé par Meta/Facebook) est une bibliothèque spécialisée dans la recherche de similarité entre vecteurs numériques. Concrètement : quand un utilisateur pose une question, on la transforme en vecteur, et FAISS trouve en quelques millisecondes les vecteurs les plus "proches" dans la base - c'est-à-dire les passages les plus similaires sémantiquement.</a:t>
+              <a:t>FAISS (développé par Meta/Facebook) est une bibliothèque spécialisée dans la recherche de similarité entre vecteurs numériques. </a:t>
+            </a:r>
+          </a:p>
+          <a:p>
+            <a:pPr marL="0" marR="0" lvl="0" indent="0" algn="l" defTabSz="914400" rtl="0" eaLnBrk="1" fontAlgn="auto" latinLnBrk="0" hangingPunct="1">
+              <a:lnSpc>
+                <a:spcPct val="100000"/>
+              </a:lnSpc>
+              <a:spcBef>
+                <a:spcPts val="0"/>
+              </a:spcBef>
+              <a:spcAft>
+                <a:spcPts val="0"/>
+              </a:spcAft>
+              <a:buClrTx/>
+              <a:buSzTx/>
+              <a:buFontTx/>
+              <a:buNone/>
+              <a:tabLst/>
+              <a:defRPr/>
+            </a:pPr>
+            <a:endParaRPr lang="fr-FR" sz="1200" b="0" kern="1200" dirty="0">
+              <a:solidFill>
+                <a:schemeClr val="tx1"/>
+              </a:solidFill>
+              <a:effectLst/>
+              <a:latin typeface="+mn-lt"/>
+              <a:ea typeface="+mn-ea"/>
+              <a:cs typeface="+mn-cs"/>
+            </a:endParaRPr>
+          </a:p>
+          <a:p>
+            <a:pPr marL="0" marR="0" lvl="0" indent="0" algn="l" defTabSz="914400" rtl="0" eaLnBrk="1" fontAlgn="auto" latinLnBrk="0" hangingPunct="1">
+              <a:lnSpc>
+                <a:spcPct val="100000"/>
+              </a:lnSpc>
+              <a:spcBef>
+                <a:spcPts val="0"/>
+              </a:spcBef>
+              <a:spcAft>
+                <a:spcPts val="0"/>
+              </a:spcAft>
+              <a:buClrTx/>
+              <a:buSzTx/>
+              <a:buFontTx/>
+              <a:buNone/>
+              <a:tabLst/>
+              <a:defRPr/>
+            </a:pPr>
+            <a:r>
+              <a:rPr lang="fr-FR" sz="1200" b="0" kern="1200" dirty="0">
+                <a:solidFill>
+                  <a:schemeClr val="tx1"/>
+                </a:solidFill>
+                <a:effectLst/>
+                <a:latin typeface="+mn-lt"/>
+                <a:ea typeface="+mn-ea"/>
+                <a:cs typeface="+mn-cs"/>
+              </a:rPr>
+              <a:t>Concrètement : quand un utilisateur pose une question, on la transforme en vecteur, et FAISS trouve en quelques millisecondes les vecteurs les plus "proches" dans la base - c'est-à-dire les passages les plus similaires sémantiquement.</a:t>
+            </a:r>
+          </a:p>
+          <a:p>
+            <a:endParaRPr lang="fr-FR" b="0" i="0" u="none" dirty="0">
+              <a:solidFill>
+                <a:schemeClr val="bg1"/>
+              </a:solidFill>
+            </a:endParaRPr>
+          </a:p>
+          <a:p>
+            <a:pPr marL="0" marR="0" lvl="0" indent="0" algn="l" defTabSz="914400" rtl="0" eaLnBrk="1" fontAlgn="auto" latinLnBrk="0" hangingPunct="1">
+              <a:lnSpc>
+                <a:spcPct val="100000"/>
+              </a:lnSpc>
+              <a:spcBef>
+                <a:spcPts val="0"/>
+              </a:spcBef>
+              <a:spcAft>
+                <a:spcPts val="0"/>
+              </a:spcAft>
+              <a:buClrTx/>
+              <a:buSzTx/>
+              <a:buFontTx/>
+              <a:buNone/>
+              <a:tabLst/>
+              <a:defRPr/>
+            </a:pPr>
+            <a:r>
+              <a:rPr lang="fr-FR" sz="1200" b="0" kern="1200" dirty="0" err="1">
+                <a:solidFill>
+                  <a:schemeClr val="tx1"/>
+                </a:solidFill>
+                <a:effectLst/>
+                <a:latin typeface="+mn-lt"/>
+                <a:ea typeface="+mn-ea"/>
+                <a:cs typeface="+mn-cs"/>
+              </a:rPr>
+              <a:t>IndexFlatIP</a:t>
+            </a:r>
+            <a:r>
+              <a:rPr lang="fr-FR" sz="1200" b="0" kern="1200" dirty="0">
+                <a:solidFill>
+                  <a:schemeClr val="tx1"/>
+                </a:solidFill>
+                <a:effectLst/>
+                <a:latin typeface="+mn-lt"/>
+                <a:ea typeface="+mn-ea"/>
+                <a:cs typeface="+mn-cs"/>
+              </a:rPr>
+              <a:t> calcule le produit scalaire entre la </a:t>
+            </a:r>
+            <a:r>
+              <a:rPr lang="fr-FR" sz="1200" b="0" kern="1200" dirty="0" err="1">
+                <a:solidFill>
+                  <a:schemeClr val="tx1"/>
+                </a:solidFill>
+                <a:effectLst/>
+                <a:latin typeface="+mn-lt"/>
+                <a:ea typeface="+mn-ea"/>
+                <a:cs typeface="+mn-cs"/>
+              </a:rPr>
+              <a:t>requete</a:t>
+            </a:r>
+            <a:r>
+              <a:rPr lang="fr-FR" sz="1200" b="0" kern="1200" dirty="0">
+                <a:solidFill>
+                  <a:schemeClr val="tx1"/>
+                </a:solidFill>
+                <a:effectLst/>
+                <a:latin typeface="+mn-lt"/>
+                <a:ea typeface="+mn-ea"/>
+                <a:cs typeface="+mn-cs"/>
+              </a:rPr>
+              <a:t> et les 10 363 vecteurs normalises (1024D). Equivalent a la </a:t>
+            </a:r>
+            <a:r>
+              <a:rPr lang="fr-FR" sz="1200" b="0" kern="1200" dirty="0" err="1">
+                <a:solidFill>
+                  <a:schemeClr val="tx1"/>
+                </a:solidFill>
+                <a:effectLst/>
+                <a:latin typeface="+mn-lt"/>
+                <a:ea typeface="+mn-ea"/>
+                <a:cs typeface="+mn-cs"/>
+              </a:rPr>
+              <a:t>similarite</a:t>
+            </a:r>
+            <a:r>
+              <a:rPr lang="fr-FR" sz="1200" b="0" kern="1200" dirty="0">
+                <a:solidFill>
+                  <a:schemeClr val="tx1"/>
+                </a:solidFill>
+                <a:effectLst/>
+                <a:latin typeface="+mn-lt"/>
+                <a:ea typeface="+mn-ea"/>
+                <a:cs typeface="+mn-cs"/>
+              </a:rPr>
+              <a:t> cosinus (donne la similarité de deux vecteurs à n dimensions en déterminant le cosinus de leur angle). </a:t>
             </a:r>
           </a:p>
           <a:p>
@@ -3827,7 +5434,7 @@
           <a:p>
             <a:fld id="{F60878AB-3368-4025-A10C-3112E0B9CFA3}" type="datetimeFigureOut">
               <a:rPr lang="fr-FR" smtClean="0"/>
-              <a:t>26/02/2026</a:t>
+              <a:t>02/03/2026</a:t>
             </a:fld>
             <a:endParaRPr lang="fr-FR"/>
           </a:p>
@@ -4025,7 +5632,7 @@
           <a:p>
             <a:fld id="{F60878AB-3368-4025-A10C-3112E0B9CFA3}" type="datetimeFigureOut">
               <a:rPr lang="fr-FR" smtClean="0"/>
-              <a:t>26/02/2026</a:t>
+              <a:t>02/03/2026</a:t>
             </a:fld>
             <a:endParaRPr lang="fr-FR"/>
           </a:p>
@@ -4233,7 +5840,7 @@
           <a:p>
             <a:fld id="{F60878AB-3368-4025-A10C-3112E0B9CFA3}" type="datetimeFigureOut">
               <a:rPr lang="fr-FR" smtClean="0"/>
-              <a:t>26/02/2026</a:t>
+              <a:t>02/03/2026</a:t>
             </a:fld>
             <a:endParaRPr lang="fr-FR"/>
           </a:p>
@@ -4431,7 +6038,7 @@
           <a:p>
             <a:fld id="{F60878AB-3368-4025-A10C-3112E0B9CFA3}" type="datetimeFigureOut">
               <a:rPr lang="fr-FR" smtClean="0"/>
-              <a:t>26/02/2026</a:t>
+              <a:t>02/03/2026</a:t>
             </a:fld>
             <a:endParaRPr lang="fr-FR"/>
           </a:p>
@@ -4706,7 +6313,7 @@
           <a:p>
             <a:fld id="{F60878AB-3368-4025-A10C-3112E0B9CFA3}" type="datetimeFigureOut">
               <a:rPr lang="fr-FR" smtClean="0"/>
-              <a:t>26/02/2026</a:t>
+              <a:t>02/03/2026</a:t>
             </a:fld>
             <a:endParaRPr lang="fr-FR"/>
           </a:p>
@@ -4971,7 +6578,7 @@
           <a:p>
             <a:fld id="{F60878AB-3368-4025-A10C-3112E0B9CFA3}" type="datetimeFigureOut">
               <a:rPr lang="fr-FR" smtClean="0"/>
-              <a:t>26/02/2026</a:t>
+              <a:t>02/03/2026</a:t>
             </a:fld>
             <a:endParaRPr lang="fr-FR"/>
           </a:p>
@@ -5383,7 +6990,7 @@
           <a:p>
             <a:fld id="{F60878AB-3368-4025-A10C-3112E0B9CFA3}" type="datetimeFigureOut">
               <a:rPr lang="fr-FR" smtClean="0"/>
-              <a:t>26/02/2026</a:t>
+              <a:t>02/03/2026</a:t>
             </a:fld>
             <a:endParaRPr lang="fr-FR"/>
           </a:p>
@@ -5524,7 +7131,7 @@
           <a:p>
             <a:fld id="{F60878AB-3368-4025-A10C-3112E0B9CFA3}" type="datetimeFigureOut">
               <a:rPr lang="fr-FR" smtClean="0"/>
-              <a:t>26/02/2026</a:t>
+              <a:t>02/03/2026</a:t>
             </a:fld>
             <a:endParaRPr lang="fr-FR"/>
           </a:p>
@@ -5637,7 +7244,7 @@
           <a:p>
             <a:fld id="{F60878AB-3368-4025-A10C-3112E0B9CFA3}" type="datetimeFigureOut">
               <a:rPr lang="fr-FR" smtClean="0"/>
-              <a:t>26/02/2026</a:t>
+              <a:t>02/03/2026</a:t>
             </a:fld>
             <a:endParaRPr lang="fr-FR"/>
           </a:p>
@@ -5948,7 +7555,7 @@
           <a:p>
             <a:fld id="{F60878AB-3368-4025-A10C-3112E0B9CFA3}" type="datetimeFigureOut">
               <a:rPr lang="fr-FR" smtClean="0"/>
-              <a:t>26/02/2026</a:t>
+              <a:t>02/03/2026</a:t>
             </a:fld>
             <a:endParaRPr lang="fr-FR"/>
           </a:p>
@@ -6236,7 +7843,7 @@
           <a:p>
             <a:fld id="{F60878AB-3368-4025-A10C-3112E0B9CFA3}" type="datetimeFigureOut">
               <a:rPr lang="fr-FR" smtClean="0"/>
-              <a:t>26/02/2026</a:t>
+              <a:t>02/03/2026</a:t>
             </a:fld>
             <a:endParaRPr lang="fr-FR"/>
           </a:p>
@@ -6492,7 +8099,7 @@
           <a:p>
             <a:fld id="{F60878AB-3368-4025-A10C-3112E0B9CFA3}" type="datetimeFigureOut">
               <a:rPr lang="fr-FR" smtClean="0"/>
-              <a:t>26/02/2026</a:t>
+              <a:t>02/03/2026</a:t>
             </a:fld>
             <a:endParaRPr lang="fr-FR"/>
           </a:p>
@@ -11490,7 +13097,7 @@
                   <a:schemeClr val="bg1"/>
                 </a:solidFill>
               </a:rPr>
-              <a:t>Quels concerts ont lieu à Toulouse en Mars 2026?</a:t>
+              <a:t>Quels concerts ont lieu à Toulouse en Mars 2026 ?</a:t>
             </a:r>
           </a:p>
           <a:p>
@@ -11557,7 +13164,7 @@
                   <a:schemeClr val="bg1"/>
                 </a:solidFill>
               </a:rPr>
-              <a:t>Quels spectacles sont adaptés aux enfants à Montpellier ?</a:t>
+              <a:t>Quels spectacles était adapté aux enfants à Montpellier en 2025 ?</a:t>
             </a:r>
           </a:p>
           <a:p>
@@ -11595,15 +13202,7 @@
                   <a:schemeClr val="bg1"/>
                 </a:solidFill>
               </a:rPr>
-              <a:t>avec noms de salles et dates</a:t>
-            </a:r>
-            <a:r>
-              <a:rPr lang="fr-FR">
-                <a:solidFill>
-                  <a:schemeClr val="bg1"/>
-                </a:solidFill>
-              </a:rPr>
-              <a:t>. </a:t>
+              <a:t>avec noms de salles et dates. </a:t>
             </a:r>
           </a:p>
           <a:p>
@@ -11632,7 +13231,7 @@
                   <a:schemeClr val="bg1"/>
                 </a:solidFill>
               </a:rPr>
-              <a:t>Y a-t-il des événements gratuits dans le Gard ce week-end ?</a:t>
+              <a:t>Y a-t-il des événements gratuits dans en Occitanie en 2026 ?</a:t>
             </a:r>
           </a:p>
           <a:p>
@@ -11699,7 +13298,7 @@
                   <a:schemeClr val="bg1"/>
                 </a:solidFill>
               </a:rPr>
-              <a:t> Quels festivals se déroulent à Carcassonne ?</a:t>
+              <a:t> Quels festivals se déroulent à Carcassonne en 2025 ?</a:t>
             </a:r>
           </a:p>
           <a:p>

</xml_diff>